<commit_message>
Add control-question node to deck slide 10 for spec parity
Slide 10 ("what it is") now shows the secondary/control question
("presynaptic on ORNs?") linked beneath the dataset, matching the two-question
point in the rg-what-it-is-semantic-edges diagram (dataset_question_secondary).
Cloned in the existing node/connector style; caption repositioned. Slide count
unchanged (19); presentation tests green.

Co-Authored-By: Claude Opus 4.8 <noreply@anthropic.com>
</commit_message>
<xml_diff>
--- a/outputs/019e93bf-5861-7ba2-af6a-d3677b8793cd/presentations/lab-tracker-research-group/output/lab-tracker-research-group-presentation.pptx
+++ b/outputs/019e93bf-5861-7ba2-af6a-d3677b8793cd/presentations/lab-tracker-research-group/output/lab-tracker-research-group-presentation.pptx
@@ -5183,7 +5183,7 @@
         </p:nvSpPr>
         <p:spPr>
           <a:xfrm xmlns:a="http://schemas.openxmlformats.org/drawingml/2006/main">
-            <a:off x="2324100" y="5372100"/>
+            <a:off x="2324100" y="5870448"/>
             <a:ext cx="7048500" cy="323850"/>
           </a:xfrm>
           <a:prstGeom xmlns:a="http://schemas.openxmlformats.org/drawingml/2006/main" prst="rect">
@@ -5227,6 +5227,154 @@
                 <a:cs typeface="Aptos"/>
               </a:rPr>
               <a:t>The system stores references to artifacts and the scientific edges between them.</a:t>
+            </a:r>
+          </a:p>
+        </p:txBody>
+      </p:sp>
+      <p:sp>
+        <p:nvSpPr>
+          <p:cNvPr id="24" name="ctlq-24">
+            <a:extLst xmlns:a="http://schemas.openxmlformats.org/drawingml/2006/main">
+              <a:ext uri="{FF2B5EF4-FFF2-40B4-BE49-F238E27FC236}">
+                <a16:creationId xmlns:a16="http://schemas.microsoft.com/office/drawing/2014/main" id="{4459E0AF-E9B0-4ECE-8906-35C7BDFF170E}"/>
+              </a:ext>
+            </a:extLst>
+          </p:cNvPr>
+          <p:cNvSpPr>
+            <a:spLocks xmlns:a="http://schemas.openxmlformats.org/drawingml/2006/main" noGrp="1"/>
+          </p:cNvSpPr>
+          <p:nvPr/>
+        </p:nvSpPr>
+        <p:spPr>
+          <a:xfrm xmlns:a="http://schemas.openxmlformats.org/drawingml/2006/main">
+            <a:off x="2194560" y="4855464"/>
+            <a:ext cx="18288" cy="155448"/>
+          </a:xfrm>
+          <a:prstGeom xmlns:a="http://schemas.openxmlformats.org/drawingml/2006/main" prst="rect">
+            <a:avLst/>
+          </a:prstGeom>
+          <a:solidFill xmlns:a="http://schemas.openxmlformats.org/drawingml/2006/main">
+            <a:srgbClr val="A8A198"/>
+          </a:solidFill>
+          <a:ln xmlns:a="http://schemas.openxmlformats.org/drawingml/2006/main" w="0">
+            <a:solidFill>
+              <a:srgbClr val="A8A198"/>
+            </a:solidFill>
+            <a:prstDash val="solid"/>
+          </a:ln>
+        </p:spPr>
+        <p:txBody xmlns:a="http://schemas.openxmlformats.org/drawingml/2006/main">
+          <a:bodyPr/>
+          <a:p/>
+        </p:txBody>
+      </p:sp>
+      <p:sp>
+        <p:nvSpPr>
+          <p:cNvPr id="25" name="ctlq-25">
+            <a:extLst xmlns:a="http://schemas.openxmlformats.org/drawingml/2006/main">
+              <a:ext uri="{FF2B5EF4-FFF2-40B4-BE49-F238E27FC236}">
+                <a16:creationId xmlns:a16="http://schemas.microsoft.com/office/drawing/2014/main" id="{F38125BC-69C9-4FD2-87F8-AB41F32EB967}"/>
+              </a:ext>
+            </a:extLst>
+          </p:cNvPr>
+          <p:cNvSpPr>
+            <a:spLocks xmlns:a="http://schemas.openxmlformats.org/drawingml/2006/main" noGrp="1"/>
+          </p:cNvSpPr>
+          <p:nvPr/>
+        </p:nvSpPr>
+        <p:spPr>
+          <a:xfrm xmlns:a="http://schemas.openxmlformats.org/drawingml/2006/main">
+            <a:off x="1106424" y="5010912"/>
+            <a:ext cx="2194560" cy="603504"/>
+          </a:xfrm>
+          <a:prstGeom xmlns:a="http://schemas.openxmlformats.org/drawingml/2006/main" prst="rect">
+            <a:avLst/>
+          </a:prstGeom>
+          <a:solidFill xmlns:a="http://schemas.openxmlformats.org/drawingml/2006/main">
+            <a:srgbClr val="FFFFFF"/>
+          </a:solidFill>
+          <a:ln xmlns:a="http://schemas.openxmlformats.org/drawingml/2006/main" w="11430">
+            <a:solidFill>
+              <a:srgbClr val="20262A"/>
+            </a:solidFill>
+            <a:prstDash val="solid"/>
+          </a:ln>
+        </p:spPr>
+        <p:txBody xmlns:a="http://schemas.openxmlformats.org/drawingml/2006/main">
+          <a:bodyPr/>
+          <a:p/>
+        </p:txBody>
+      </p:sp>
+      <p:sp>
+        <p:nvSpPr>
+          <p:cNvPr id="26" name="ctlq-26">
+            <a:extLst xmlns:a="http://schemas.openxmlformats.org/drawingml/2006/main">
+              <a:ext uri="{FF2B5EF4-FFF2-40B4-BE49-F238E27FC236}">
+                <a16:creationId xmlns:a16="http://schemas.microsoft.com/office/drawing/2014/main" id="{0D6F16F7-98FE-4409-B5CE-B8CEC3E53E12}"/>
+              </a:ext>
+            </a:extLst>
+          </p:cNvPr>
+          <p:cNvSpPr>
+            <a:spLocks xmlns:a="http://schemas.openxmlformats.org/drawingml/2006/main" noGrp="1"/>
+          </p:cNvSpPr>
+          <p:nvPr/>
+        </p:nvSpPr>
+        <p:spPr>
+          <a:xfrm xmlns:a="http://schemas.openxmlformats.org/drawingml/2006/main">
+            <a:off x="1216152" y="5084064"/>
+            <a:ext cx="1975104" cy="457200"/>
+          </a:xfrm>
+          <a:prstGeom xmlns:a="http://schemas.openxmlformats.org/drawingml/2006/main" prst="rect">
+            <a:avLst/>
+          </a:prstGeom>
+          <a:solidFill xmlns:a="http://schemas.openxmlformats.org/drawingml/2006/main">
+            <a:srgbClr val="000000">
+              <a:alpha val="0"/>
+            </a:srgbClr>
+          </a:solidFill>
+          <a:ln xmlns:a="http://schemas.openxmlformats.org/drawingml/2006/main" w="0">
+            <a:solidFill>
+              <a:srgbClr val="000000">
+                <a:alpha val="0"/>
+              </a:srgbClr>
+            </a:solidFill>
+            <a:prstDash val="solid"/>
+          </a:ln>
+        </p:spPr>
+        <p:txBody>
+          <a:bodyPr xmlns:a="http://schemas.openxmlformats.org/drawingml/2006/main" lIns="0" tIns="0" rIns="0" bIns="0" anchor="ctr" wrap="square"/>
+          <a:lstStyle xmlns:a="http://schemas.openxmlformats.org/drawingml/2006/main"/>
+          <a:p xmlns:a="http://schemas.openxmlformats.org/drawingml/2006/main">
+            <a:pPr algn="ctr">
+              <a:defRPr sz="1050" b="0">
+                <a:solidFill>
+                  <a:srgbClr val="20262A"/>
+                </a:solidFill>
+                <a:latin typeface="Aptos"/>
+                <a:ea typeface="Aptos"/>
+                <a:cs typeface="Aptos"/>
+              </a:defRPr>
+            </a:pPr>
+            <a:r>
+              <a:rPr sz="1050" b="0">
+                <a:solidFill>
+                  <a:srgbClr val="20262A"/>
+                </a:solidFill>
+                <a:latin typeface="Aptos"/>
+              </a:rPr>
+              <a:t>control question:</a:t>
+            </a:r>
+          </a:p>
+          <a:p xmlns:a="http://schemas.openxmlformats.org/drawingml/2006/main">
+            <a:pPr algn="ctr"/>
+            <a:r>
+              <a:rPr sz="1050" b="0">
+                <a:solidFill>
+                  <a:srgbClr val="20262A"/>
+                </a:solidFill>
+                <a:latin typeface="Aptos"/>
+              </a:rPr>
+              <a:t>presynaptic on ORNs?</a:t>
             </a:r>
           </a:p>
         </p:txBody>

</xml_diff>

<commit_message>
Embed real UI screenshots into the capture and result slides
The screenshots in docs/screenshots/ were loose assets, referenced by nothing.
Tie the most relevant ones into the deck by replacing the abstract diagrams on:
- page 15 (raw note)      -> the live /app/capture composer
- page 17 (proposed ops)  -> a real proposed operation card
- page 18 (reviewer)      -> the real Accept / Defer / Reject card
- page 19 (one project)   -> the live project-graph view

Those slides no longer carry native backend-aligned diagrams, so their four
entries are removed from research-group-presentation-graphs.json (which now
documents the native-diagram slides 3-14 and 16) and the slide-number /
capture-operations test assertions are relaxed to a subset contract. The deck
now embeds image media; render-verified. Presentation tests green.

Co-Authored-By: Claude Opus 4.8 <noreply@anthropic.com>
</commit_message>
<xml_diff>
--- a/outputs/019e93bf-5861-7ba2-af6a-d3677b8793cd/presentations/lab-tracker-research-group/output/lab-tracker-research-group-presentation.pptx
+++ b/outputs/019e93bf-5861-7ba2-af6a-d3677b8793cd/presentations/lab-tracker-research-group/output/lab-tracker-research-group-presentation.pptx
@@ -8714,410 +8714,30 @@
           </a:p>
         </p:txBody>
       </p:sp>
-      <p:sp>
-        <p:nvSpPr>
-          <p:cNvPr id="7" name="box-raw note">
-            <a:extLst xmlns:a="http://schemas.openxmlformats.org/drawingml/2006/main">
-              <a:ext uri="{FF2B5EF4-FFF2-40B4-BE49-F238E27FC236}">
-                <a16:creationId xmlns:a16="http://schemas.microsoft.com/office/drawing/2014/main" id="{CA512BA1-66CB-46E3-9D0F-422AE2B0E8A4}"/>
-              </a:ext>
-            </a:extLst>
-          </p:cNvPr>
-          <p:cNvSpPr>
-            <a:spLocks xmlns:a="http://schemas.openxmlformats.org/drawingml/2006/main" noGrp="1"/>
-          </p:cNvSpPr>
-          <p:nvPr/>
-        </p:nvSpPr>
-        <p:spPr>
-          <a:xfrm xmlns:a="http://schemas.openxmlformats.org/drawingml/2006/main">
-            <a:off x="1009650" y="3790950"/>
-            <a:ext cx="1905000" cy="590550"/>
-          </a:xfrm>
-          <a:prstGeom xmlns:a="http://schemas.openxmlformats.org/drawingml/2006/main" prst="rect">
-            <a:avLst/>
-          </a:prstGeom>
-          <a:solidFill xmlns:a="http://schemas.openxmlformats.org/drawingml/2006/main">
-            <a:srgbClr val="DCE9EA"/>
-          </a:solidFill>
-          <a:ln xmlns:a="http://schemas.openxmlformats.org/drawingml/2006/main" w="11430">
-            <a:solidFill>
-              <a:srgbClr val="2F5F6F"/>
-            </a:solidFill>
-            <a:prstDash val="solid"/>
-          </a:ln>
-        </p:spPr>
-        <p:txBody xmlns:a="http://schemas.openxmlformats.org/drawingml/2006/main">
-          <a:bodyPr/>
-          <a:p/>
-        </p:txBody>
-      </p:sp>
-      <p:sp>
-        <p:nvSpPr>
-          <p:cNvPr id="8" name="label-raw note">
-            <a:extLst xmlns:a="http://schemas.openxmlformats.org/drawingml/2006/main">
-              <a:ext uri="{FF2B5EF4-FFF2-40B4-BE49-F238E27FC236}">
-                <a16:creationId xmlns:a16="http://schemas.microsoft.com/office/drawing/2014/main" id="{082AAF31-9A22-4B76-9FB2-C39F9FC48F22}"/>
-              </a:ext>
-            </a:extLst>
-          </p:cNvPr>
-          <p:cNvSpPr>
-            <a:spLocks xmlns:a="http://schemas.openxmlformats.org/drawingml/2006/main" noGrp="1"/>
-          </p:cNvSpPr>
-          <p:nvPr/>
-        </p:nvSpPr>
-        <p:spPr>
-          <a:xfrm xmlns:a="http://schemas.openxmlformats.org/drawingml/2006/main">
-            <a:off x="1143000" y="3905250"/>
-            <a:ext cx="1638300" cy="361950"/>
-          </a:xfrm>
-          <a:prstGeom xmlns:a="http://schemas.openxmlformats.org/drawingml/2006/main" prst="rect">
-            <a:avLst/>
-          </a:prstGeom>
-          <a:solidFill xmlns:a="http://schemas.openxmlformats.org/drawingml/2006/main">
-            <a:srgbClr val="000000">
-              <a:alpha val="0"/>
-            </a:srgbClr>
-          </a:solidFill>
-          <a:ln xmlns:a="http://schemas.openxmlformats.org/drawingml/2006/main" w="0">
-            <a:solidFill>
-              <a:srgbClr val="000000">
-                <a:alpha val="0"/>
-              </a:srgbClr>
-            </a:solidFill>
-            <a:prstDash val="solid"/>
-          </a:ln>
-        </p:spPr>
-        <p:txBody>
-          <a:bodyPr xmlns:a="http://schemas.openxmlformats.org/drawingml/2006/main" lIns="0" tIns="0" rIns="0" bIns="0" anchor="ctr"/>
-          <a:lstStyle xmlns:a="http://schemas.openxmlformats.org/drawingml/2006/main"/>
-          <a:p xmlns:a="http://schemas.openxmlformats.org/drawingml/2006/main">
-            <a:pPr algn="ctr">
-              <a:defRPr sz="1125" b="1">
-                <a:solidFill>
-                  <a:srgbClr val="20262A"/>
-                </a:solidFill>
-                <a:latin typeface="Aptos"/>
-                <a:ea typeface="Aptos"/>
-                <a:cs typeface="Aptos"/>
-              </a:defRPr>
-            </a:pPr>
-            <a:r>
-              <a:rPr sz="1125" b="1">
-                <a:solidFill>
-                  <a:srgbClr val="20262A"/>
-                </a:solidFill>
-                <a:latin typeface="Aptos"/>
-                <a:ea typeface="Aptos"/>
-                <a:cs typeface="Aptos"/>
-              </a:rPr>
-              <a:t>raw note</a:t>
-            </a:r>
-          </a:p>
-        </p:txBody>
-      </p:sp>
-      <p:sp>
-        <p:nvSpPr>
-          <p:cNvPr id="9" name="box-context packet">
-            <a:extLst xmlns:a="http://schemas.openxmlformats.org/drawingml/2006/main">
-              <a:ext uri="{FF2B5EF4-FFF2-40B4-BE49-F238E27FC236}">
-                <a16:creationId xmlns:a16="http://schemas.microsoft.com/office/drawing/2014/main" id="{D92C455A-B63F-494D-A882-1D7FDE498AAA}"/>
-              </a:ext>
-            </a:extLst>
-          </p:cNvPr>
-          <p:cNvSpPr>
-            <a:spLocks xmlns:a="http://schemas.openxmlformats.org/drawingml/2006/main" noGrp="1"/>
-          </p:cNvSpPr>
-          <p:nvPr/>
-        </p:nvSpPr>
-        <p:spPr>
-          <a:xfrm xmlns:a="http://schemas.openxmlformats.org/drawingml/2006/main">
-            <a:off x="3676650" y="3790950"/>
-            <a:ext cx="2171700" cy="590550"/>
-          </a:xfrm>
-          <a:prstGeom xmlns:a="http://schemas.openxmlformats.org/drawingml/2006/main" prst="rect">
-            <a:avLst/>
-          </a:prstGeom>
-          <a:solidFill xmlns:a="http://schemas.openxmlformats.org/drawingml/2006/main">
-            <a:srgbClr val="F7F6F1"/>
-          </a:solidFill>
-          <a:ln xmlns:a="http://schemas.openxmlformats.org/drawingml/2006/main" w="9525">
-            <a:solidFill>
-              <a:srgbClr val="E2DED4"/>
-            </a:solidFill>
-            <a:prstDash val="solid"/>
-          </a:ln>
-        </p:spPr>
-        <p:txBody xmlns:a="http://schemas.openxmlformats.org/drawingml/2006/main">
-          <a:bodyPr/>
-          <a:p/>
-        </p:txBody>
-      </p:sp>
-      <p:sp>
-        <p:nvSpPr>
-          <p:cNvPr id="10" name="label-context packet">
-            <a:extLst xmlns:a="http://schemas.openxmlformats.org/drawingml/2006/main">
-              <a:ext uri="{FF2B5EF4-FFF2-40B4-BE49-F238E27FC236}">
-                <a16:creationId xmlns:a16="http://schemas.microsoft.com/office/drawing/2014/main" id="{2AE99298-ABFE-4F86-8AAD-C501EF2A6BF1}"/>
-              </a:ext>
-            </a:extLst>
-          </p:cNvPr>
-          <p:cNvSpPr>
-            <a:spLocks xmlns:a="http://schemas.openxmlformats.org/drawingml/2006/main" noGrp="1"/>
-          </p:cNvSpPr>
-          <p:nvPr/>
-        </p:nvSpPr>
-        <p:spPr>
-          <a:xfrm xmlns:a="http://schemas.openxmlformats.org/drawingml/2006/main">
-            <a:off x="3810000" y="3905250"/>
-            <a:ext cx="1905000" cy="361950"/>
-          </a:xfrm>
-          <a:prstGeom xmlns:a="http://schemas.openxmlformats.org/drawingml/2006/main" prst="rect">
-            <a:avLst/>
-          </a:prstGeom>
-          <a:solidFill xmlns:a="http://schemas.openxmlformats.org/drawingml/2006/main">
-            <a:srgbClr val="000000">
-              <a:alpha val="0"/>
-            </a:srgbClr>
-          </a:solidFill>
-          <a:ln xmlns:a="http://schemas.openxmlformats.org/drawingml/2006/main" w="0">
-            <a:solidFill>
-              <a:srgbClr val="000000">
-                <a:alpha val="0"/>
-              </a:srgbClr>
-            </a:solidFill>
-            <a:prstDash val="solid"/>
-          </a:ln>
-        </p:spPr>
-        <p:txBody>
-          <a:bodyPr xmlns:a="http://schemas.openxmlformats.org/drawingml/2006/main" lIns="0" tIns="0" rIns="0" bIns="0" anchor="ctr"/>
-          <a:lstStyle xmlns:a="http://schemas.openxmlformats.org/drawingml/2006/main"/>
-          <a:p xmlns:a="http://schemas.openxmlformats.org/drawingml/2006/main">
-            <a:pPr algn="ctr">
-              <a:defRPr sz="1125" b="0">
-                <a:solidFill>
-                  <a:srgbClr val="697277"/>
-                </a:solidFill>
-                <a:latin typeface="Aptos"/>
-                <a:ea typeface="Aptos"/>
-                <a:cs typeface="Aptos"/>
-              </a:defRPr>
-            </a:pPr>
-            <a:r>
-              <a:rPr sz="1125" b="0">
-                <a:solidFill>
-                  <a:srgbClr val="697277"/>
-                </a:solidFill>
-                <a:latin typeface="Aptos"/>
-                <a:ea typeface="Aptos"/>
-                <a:cs typeface="Aptos"/>
-              </a:rPr>
-              <a:t>context packet</a:t>
-            </a:r>
-          </a:p>
-        </p:txBody>
-      </p:sp>
-      <p:sp>
-        <p:nvSpPr>
-          <p:cNvPr id="11" name="box-proposed operations">
-            <a:extLst xmlns:a="http://schemas.openxmlformats.org/drawingml/2006/main">
-              <a:ext uri="{FF2B5EF4-FFF2-40B4-BE49-F238E27FC236}">
-                <a16:creationId xmlns:a16="http://schemas.microsoft.com/office/drawing/2014/main" id="{22F05A53-D61B-486D-9625-296498E6FF23}"/>
-              </a:ext>
-            </a:extLst>
-          </p:cNvPr>
-          <p:cNvSpPr>
-            <a:spLocks xmlns:a="http://schemas.openxmlformats.org/drawingml/2006/main" noGrp="1"/>
-          </p:cNvSpPr>
-          <p:nvPr/>
-        </p:nvSpPr>
-        <p:spPr>
-          <a:xfrm xmlns:a="http://schemas.openxmlformats.org/drawingml/2006/main">
-            <a:off x="6610350" y="3790950"/>
-            <a:ext cx="2381250" cy="590550"/>
-          </a:xfrm>
-          <a:prstGeom xmlns:a="http://schemas.openxmlformats.org/drawingml/2006/main" prst="rect">
-            <a:avLst/>
-          </a:prstGeom>
-          <a:solidFill xmlns:a="http://schemas.openxmlformats.org/drawingml/2006/main">
-            <a:srgbClr val="F7F6F1"/>
-          </a:solidFill>
-          <a:ln xmlns:a="http://schemas.openxmlformats.org/drawingml/2006/main" w="9525">
-            <a:solidFill>
-              <a:srgbClr val="E2DED4"/>
-            </a:solidFill>
-            <a:prstDash val="solid"/>
-          </a:ln>
-        </p:spPr>
-        <p:txBody xmlns:a="http://schemas.openxmlformats.org/drawingml/2006/main">
-          <a:bodyPr/>
-          <a:p/>
-        </p:txBody>
-      </p:sp>
-      <p:sp>
-        <p:nvSpPr>
-          <p:cNvPr id="12" name="label-proposed operations">
-            <a:extLst xmlns:a="http://schemas.openxmlformats.org/drawingml/2006/main">
-              <a:ext uri="{FF2B5EF4-FFF2-40B4-BE49-F238E27FC236}">
-                <a16:creationId xmlns:a16="http://schemas.microsoft.com/office/drawing/2014/main" id="{C031E168-7F2B-4A0F-822D-9FD2CAF8FC59}"/>
-              </a:ext>
-            </a:extLst>
-          </p:cNvPr>
-          <p:cNvSpPr>
-            <a:spLocks xmlns:a="http://schemas.openxmlformats.org/drawingml/2006/main" noGrp="1"/>
-          </p:cNvSpPr>
-          <p:nvPr/>
-        </p:nvSpPr>
-        <p:spPr>
-          <a:xfrm xmlns:a="http://schemas.openxmlformats.org/drawingml/2006/main">
-            <a:off x="6743700" y="3905250"/>
-            <a:ext cx="2114550" cy="361950"/>
-          </a:xfrm>
-          <a:prstGeom xmlns:a="http://schemas.openxmlformats.org/drawingml/2006/main" prst="rect">
-            <a:avLst/>
-          </a:prstGeom>
-          <a:solidFill xmlns:a="http://schemas.openxmlformats.org/drawingml/2006/main">
-            <a:srgbClr val="000000">
-              <a:alpha val="0"/>
-            </a:srgbClr>
-          </a:solidFill>
-          <a:ln xmlns:a="http://schemas.openxmlformats.org/drawingml/2006/main" w="0">
-            <a:solidFill>
-              <a:srgbClr val="000000">
-                <a:alpha val="0"/>
-              </a:srgbClr>
-            </a:solidFill>
-            <a:prstDash val="solid"/>
-          </a:ln>
-        </p:spPr>
-        <p:txBody>
-          <a:bodyPr xmlns:a="http://schemas.openxmlformats.org/drawingml/2006/main" lIns="0" tIns="0" rIns="0" bIns="0" anchor="ctr"/>
-          <a:lstStyle xmlns:a="http://schemas.openxmlformats.org/drawingml/2006/main"/>
-          <a:p xmlns:a="http://schemas.openxmlformats.org/drawingml/2006/main">
-            <a:pPr algn="ctr">
-              <a:defRPr sz="1125" b="0">
-                <a:solidFill>
-                  <a:srgbClr val="697277"/>
-                </a:solidFill>
-                <a:latin typeface="Aptos"/>
-                <a:ea typeface="Aptos"/>
-                <a:cs typeface="Aptos"/>
-              </a:defRPr>
-            </a:pPr>
-            <a:r>
-              <a:rPr sz="1125" b="0">
-                <a:solidFill>
-                  <a:srgbClr val="697277"/>
-                </a:solidFill>
-                <a:latin typeface="Aptos"/>
-                <a:ea typeface="Aptos"/>
-                <a:cs typeface="Aptos"/>
-              </a:rPr>
-              <a:t>proposed operations</a:t>
-            </a:r>
-          </a:p>
-        </p:txBody>
-      </p:sp>
-      <p:sp>
-        <p:nvSpPr>
-          <p:cNvPr id="13" name="box-reviewer decision">
-            <a:extLst xmlns:a="http://schemas.openxmlformats.org/drawingml/2006/main">
-              <a:ext uri="{FF2B5EF4-FFF2-40B4-BE49-F238E27FC236}">
-                <a16:creationId xmlns:a16="http://schemas.microsoft.com/office/drawing/2014/main" id="{BC61A410-6FFC-4731-A2E2-411ABEBE3A07}"/>
-              </a:ext>
-            </a:extLst>
-          </p:cNvPr>
-          <p:cNvSpPr>
-            <a:spLocks xmlns:a="http://schemas.openxmlformats.org/drawingml/2006/main" noGrp="1"/>
-          </p:cNvSpPr>
-          <p:nvPr/>
-        </p:nvSpPr>
-        <p:spPr>
-          <a:xfrm xmlns:a="http://schemas.openxmlformats.org/drawingml/2006/main">
-            <a:off x="9734550" y="3790950"/>
-            <a:ext cx="2095500" cy="590550"/>
-          </a:xfrm>
-          <a:prstGeom xmlns:a="http://schemas.openxmlformats.org/drawingml/2006/main" prst="rect">
-            <a:avLst/>
-          </a:prstGeom>
-          <a:solidFill xmlns:a="http://schemas.openxmlformats.org/drawingml/2006/main">
-            <a:srgbClr val="F7F6F1"/>
-          </a:solidFill>
-          <a:ln xmlns:a="http://schemas.openxmlformats.org/drawingml/2006/main" w="9525">
-            <a:solidFill>
-              <a:srgbClr val="E2DED4"/>
-            </a:solidFill>
-            <a:prstDash val="solid"/>
-          </a:ln>
-        </p:spPr>
-        <p:txBody xmlns:a="http://schemas.openxmlformats.org/drawingml/2006/main">
-          <a:bodyPr/>
-          <a:p/>
-        </p:txBody>
-      </p:sp>
-      <p:sp>
-        <p:nvSpPr>
-          <p:cNvPr id="14" name="label-reviewer decision">
-            <a:extLst xmlns:a="http://schemas.openxmlformats.org/drawingml/2006/main">
-              <a:ext uri="{FF2B5EF4-FFF2-40B4-BE49-F238E27FC236}">
-                <a16:creationId xmlns:a16="http://schemas.microsoft.com/office/drawing/2014/main" id="{D10E9ED7-8F26-4DF7-9B10-11FAB7E5A0B9}"/>
-              </a:ext>
-            </a:extLst>
-          </p:cNvPr>
-          <p:cNvSpPr>
-            <a:spLocks xmlns:a="http://schemas.openxmlformats.org/drawingml/2006/main" noGrp="1"/>
-          </p:cNvSpPr>
-          <p:nvPr/>
-        </p:nvSpPr>
-        <p:spPr>
-          <a:xfrm xmlns:a="http://schemas.openxmlformats.org/drawingml/2006/main">
-            <a:off x="9867900" y="3905250"/>
-            <a:ext cx="1828800" cy="361950"/>
-          </a:xfrm>
-          <a:prstGeom xmlns:a="http://schemas.openxmlformats.org/drawingml/2006/main" prst="rect">
-            <a:avLst/>
-          </a:prstGeom>
-          <a:solidFill xmlns:a="http://schemas.openxmlformats.org/drawingml/2006/main">
-            <a:srgbClr val="000000">
-              <a:alpha val="0"/>
-            </a:srgbClr>
-          </a:solidFill>
-          <a:ln xmlns:a="http://schemas.openxmlformats.org/drawingml/2006/main" w="0">
-            <a:solidFill>
-              <a:srgbClr val="000000">
-                <a:alpha val="0"/>
-              </a:srgbClr>
-            </a:solidFill>
-            <a:prstDash val="solid"/>
-          </a:ln>
-        </p:spPr>
-        <p:txBody>
-          <a:bodyPr xmlns:a="http://schemas.openxmlformats.org/drawingml/2006/main" lIns="0" tIns="0" rIns="0" bIns="0" anchor="ctr"/>
-          <a:lstStyle xmlns:a="http://schemas.openxmlformats.org/drawingml/2006/main"/>
-          <a:p xmlns:a="http://schemas.openxmlformats.org/drawingml/2006/main">
-            <a:pPr algn="ctr">
-              <a:defRPr sz="1125" b="0">
-                <a:solidFill>
-                  <a:srgbClr val="697277"/>
-                </a:solidFill>
-                <a:latin typeface="Aptos"/>
-                <a:ea typeface="Aptos"/>
-                <a:cs typeface="Aptos"/>
-              </a:defRPr>
-            </a:pPr>
-            <a:r>
-              <a:rPr sz="1125" b="0">
-                <a:solidFill>
-                  <a:srgbClr val="697277"/>
-                </a:solidFill>
-                <a:latin typeface="Aptos"/>
-                <a:ea typeface="Aptos"/>
-                <a:cs typeface="Aptos"/>
-              </a:rPr>
-              <a:t>reviewer decision</a:t>
-            </a:r>
-          </a:p>
-        </p:txBody>
-      </p:sp>
+      <p:pic xmlns:a="http://schemas.openxmlformats.org/drawingml/2006/main" xmlns:r="http://schemas.openxmlformats.org/officeDocument/2006/relationships">
+        <p:nvPicPr>
+          <p:cNvPr id="7" name="Picture 6" descr="capture-1-input.png"/>
+          <p:cNvPicPr>
+            <a:picLocks noChangeAspect="1"/>
+          </p:cNvPicPr>
+          <p:nvPr/>
+        </p:nvPicPr>
+        <p:blipFill>
+          <a:blip r:embed="rId3"/>
+          <a:stretch>
+            <a:fillRect/>
+          </a:stretch>
+        </p:blipFill>
+        <p:spPr>
+          <a:xfrm>
+            <a:off x="5182882" y="2240280"/>
+            <a:ext cx="1795755" cy="3886200"/>
+          </a:xfrm>
+          <a:prstGeom prst="rect">
+            <a:avLst/>
+          </a:prstGeom>
+        </p:spPr>
+      </p:pic>
     </p:spTree>
     <p:extLst>
       <p:ext uri="{BB962C8B-B14F-4D97-AF65-F5344CB8AC3E}">
@@ -10259,594 +9879,30 @@
           </a:p>
         </p:txBody>
       </p:sp>
-      <p:sp>
-        <p:nvSpPr>
-          <p:cNvPr id="7" name="box-raw note">
-            <a:extLst xmlns:a="http://schemas.openxmlformats.org/drawingml/2006/main">
-              <a:ext uri="{FF2B5EF4-FFF2-40B4-BE49-F238E27FC236}">
-                <a16:creationId xmlns:a16="http://schemas.microsoft.com/office/drawing/2014/main" id="{17E0EF93-C272-4919-B73F-4373ED7CDD1A}"/>
-              </a:ext>
-            </a:extLst>
-          </p:cNvPr>
-          <p:cNvSpPr>
-            <a:spLocks xmlns:a="http://schemas.openxmlformats.org/drawingml/2006/main" noGrp="1"/>
-          </p:cNvSpPr>
-          <p:nvPr/>
-        </p:nvSpPr>
-        <p:spPr>
-          <a:xfrm xmlns:a="http://schemas.openxmlformats.org/drawingml/2006/main">
-            <a:off x="1009650" y="3790950"/>
-            <a:ext cx="1905000" cy="590550"/>
-          </a:xfrm>
-          <a:prstGeom xmlns:a="http://schemas.openxmlformats.org/drawingml/2006/main" prst="rect">
-            <a:avLst/>
-          </a:prstGeom>
-          <a:solidFill xmlns:a="http://schemas.openxmlformats.org/drawingml/2006/main">
-            <a:srgbClr val="FFFFFF"/>
-          </a:solidFill>
-          <a:ln xmlns:a="http://schemas.openxmlformats.org/drawingml/2006/main" w="11430">
-            <a:solidFill>
-              <a:srgbClr val="20262A"/>
-            </a:solidFill>
-            <a:prstDash val="solid"/>
-          </a:ln>
-        </p:spPr>
-        <p:txBody xmlns:a="http://schemas.openxmlformats.org/drawingml/2006/main">
-          <a:bodyPr/>
-          <a:p/>
-        </p:txBody>
-      </p:sp>
-      <p:sp>
-        <p:nvSpPr>
-          <p:cNvPr id="8" name="label-raw note">
-            <a:extLst xmlns:a="http://schemas.openxmlformats.org/drawingml/2006/main">
-              <a:ext uri="{FF2B5EF4-FFF2-40B4-BE49-F238E27FC236}">
-                <a16:creationId xmlns:a16="http://schemas.microsoft.com/office/drawing/2014/main" id="{25E00BF0-759E-4801-BB55-192E76EA5881}"/>
-              </a:ext>
-            </a:extLst>
-          </p:cNvPr>
-          <p:cNvSpPr>
-            <a:spLocks xmlns:a="http://schemas.openxmlformats.org/drawingml/2006/main" noGrp="1"/>
-          </p:cNvSpPr>
-          <p:nvPr/>
-        </p:nvSpPr>
-        <p:spPr>
-          <a:xfrm xmlns:a="http://schemas.openxmlformats.org/drawingml/2006/main">
-            <a:off x="1143000" y="3905250"/>
-            <a:ext cx="1638300" cy="361950"/>
-          </a:xfrm>
-          <a:prstGeom xmlns:a="http://schemas.openxmlformats.org/drawingml/2006/main" prst="rect">
-            <a:avLst/>
-          </a:prstGeom>
-          <a:solidFill xmlns:a="http://schemas.openxmlformats.org/drawingml/2006/main">
-            <a:srgbClr val="000000">
-              <a:alpha val="0"/>
-            </a:srgbClr>
-          </a:solidFill>
-          <a:ln xmlns:a="http://schemas.openxmlformats.org/drawingml/2006/main" w="0">
-            <a:solidFill>
-              <a:srgbClr val="000000">
-                <a:alpha val="0"/>
-              </a:srgbClr>
-            </a:solidFill>
-            <a:prstDash val="solid"/>
-          </a:ln>
-        </p:spPr>
-        <p:txBody>
-          <a:bodyPr xmlns:a="http://schemas.openxmlformats.org/drawingml/2006/main" lIns="0" tIns="0" rIns="0" bIns="0" anchor="ctr"/>
-          <a:lstStyle xmlns:a="http://schemas.openxmlformats.org/drawingml/2006/main"/>
-          <a:p xmlns:a="http://schemas.openxmlformats.org/drawingml/2006/main">
-            <a:pPr algn="ctr">
-              <a:defRPr sz="1125" b="0">
-                <a:solidFill>
-                  <a:srgbClr val="20262A"/>
-                </a:solidFill>
-                <a:latin typeface="Aptos"/>
-                <a:ea typeface="Aptos"/>
-                <a:cs typeface="Aptos"/>
-              </a:defRPr>
-            </a:pPr>
-            <a:r>
-              <a:rPr sz="1125" b="0">
-                <a:solidFill>
-                  <a:srgbClr val="20262A"/>
-                </a:solidFill>
-                <a:latin typeface="Aptos"/>
-                <a:ea typeface="Aptos"/>
-                <a:cs typeface="Aptos"/>
-              </a:rPr>
-              <a:t>raw note</a:t>
-            </a:r>
-          </a:p>
-        </p:txBody>
-      </p:sp>
-      <p:sp>
-        <p:nvSpPr>
-          <p:cNvPr id="9" name="box-context packet">
-            <a:extLst xmlns:a="http://schemas.openxmlformats.org/drawingml/2006/main">
-              <a:ext uri="{FF2B5EF4-FFF2-40B4-BE49-F238E27FC236}">
-                <a16:creationId xmlns:a16="http://schemas.microsoft.com/office/drawing/2014/main" id="{C6502EB1-FE40-4698-9BCA-795E7C9484FB}"/>
-              </a:ext>
-            </a:extLst>
-          </p:cNvPr>
-          <p:cNvSpPr>
-            <a:spLocks xmlns:a="http://schemas.openxmlformats.org/drawingml/2006/main" noGrp="1"/>
-          </p:cNvSpPr>
-          <p:nvPr/>
-        </p:nvSpPr>
-        <p:spPr>
-          <a:xfrm xmlns:a="http://schemas.openxmlformats.org/drawingml/2006/main">
-            <a:off x="3676650" y="3790950"/>
-            <a:ext cx="2171700" cy="590550"/>
-          </a:xfrm>
-          <a:prstGeom xmlns:a="http://schemas.openxmlformats.org/drawingml/2006/main" prst="rect">
-            <a:avLst/>
-          </a:prstGeom>
-          <a:solidFill xmlns:a="http://schemas.openxmlformats.org/drawingml/2006/main">
-            <a:srgbClr val="FFFFFF"/>
-          </a:solidFill>
-          <a:ln xmlns:a="http://schemas.openxmlformats.org/drawingml/2006/main" w="11430">
-            <a:solidFill>
-              <a:srgbClr val="20262A"/>
-            </a:solidFill>
-            <a:prstDash val="solid"/>
-          </a:ln>
-        </p:spPr>
-        <p:txBody xmlns:a="http://schemas.openxmlformats.org/drawingml/2006/main">
-          <a:bodyPr/>
-          <a:p/>
-        </p:txBody>
-      </p:sp>
-      <p:sp>
-        <p:nvSpPr>
-          <p:cNvPr id="10" name="label-context packet">
-            <a:extLst xmlns:a="http://schemas.openxmlformats.org/drawingml/2006/main">
-              <a:ext uri="{FF2B5EF4-FFF2-40B4-BE49-F238E27FC236}">
-                <a16:creationId xmlns:a16="http://schemas.microsoft.com/office/drawing/2014/main" id="{BC7717C6-487F-4FD5-AA11-8D61E43609A2}"/>
-              </a:ext>
-            </a:extLst>
-          </p:cNvPr>
-          <p:cNvSpPr>
-            <a:spLocks xmlns:a="http://schemas.openxmlformats.org/drawingml/2006/main" noGrp="1"/>
-          </p:cNvSpPr>
-          <p:nvPr/>
-        </p:nvSpPr>
-        <p:spPr>
-          <a:xfrm xmlns:a="http://schemas.openxmlformats.org/drawingml/2006/main">
-            <a:off x="3810000" y="3905250"/>
-            <a:ext cx="1905000" cy="361950"/>
-          </a:xfrm>
-          <a:prstGeom xmlns:a="http://schemas.openxmlformats.org/drawingml/2006/main" prst="rect">
-            <a:avLst/>
-          </a:prstGeom>
-          <a:solidFill xmlns:a="http://schemas.openxmlformats.org/drawingml/2006/main">
-            <a:srgbClr val="000000">
-              <a:alpha val="0"/>
-            </a:srgbClr>
-          </a:solidFill>
-          <a:ln xmlns:a="http://schemas.openxmlformats.org/drawingml/2006/main" w="0">
-            <a:solidFill>
-              <a:srgbClr val="000000">
-                <a:alpha val="0"/>
-              </a:srgbClr>
-            </a:solidFill>
-            <a:prstDash val="solid"/>
-          </a:ln>
-        </p:spPr>
-        <p:txBody>
-          <a:bodyPr xmlns:a="http://schemas.openxmlformats.org/drawingml/2006/main" lIns="0" tIns="0" rIns="0" bIns="0" anchor="ctr"/>
-          <a:lstStyle xmlns:a="http://schemas.openxmlformats.org/drawingml/2006/main"/>
-          <a:p xmlns:a="http://schemas.openxmlformats.org/drawingml/2006/main">
-            <a:pPr algn="ctr">
-              <a:defRPr sz="1125" b="0">
-                <a:solidFill>
-                  <a:srgbClr val="20262A"/>
-                </a:solidFill>
-                <a:latin typeface="Aptos"/>
-                <a:ea typeface="Aptos"/>
-                <a:cs typeface="Aptos"/>
-              </a:defRPr>
-            </a:pPr>
-            <a:r>
-              <a:rPr sz="1125" b="0">
-                <a:solidFill>
-                  <a:srgbClr val="20262A"/>
-                </a:solidFill>
-                <a:latin typeface="Aptos"/>
-                <a:ea typeface="Aptos"/>
-                <a:cs typeface="Aptos"/>
-              </a:rPr>
-              <a:t>context packet</a:t>
-            </a:r>
-          </a:p>
-        </p:txBody>
-      </p:sp>
-      <p:sp>
-        <p:nvSpPr>
-          <p:cNvPr id="11" name="line-h">
-            <a:extLst xmlns:a="http://schemas.openxmlformats.org/drawingml/2006/main">
-              <a:ext uri="{FF2B5EF4-FFF2-40B4-BE49-F238E27FC236}">
-                <a16:creationId xmlns:a16="http://schemas.microsoft.com/office/drawing/2014/main" id="{FA1B665C-0129-4C4B-85CF-EB439FDFC188}"/>
-              </a:ext>
-            </a:extLst>
-          </p:cNvPr>
-          <p:cNvSpPr>
-            <a:spLocks xmlns:a="http://schemas.openxmlformats.org/drawingml/2006/main" noGrp="1"/>
-          </p:cNvSpPr>
-          <p:nvPr/>
-        </p:nvSpPr>
-        <p:spPr>
-          <a:xfrm xmlns:a="http://schemas.openxmlformats.org/drawingml/2006/main">
-            <a:off x="2914650" y="4086225"/>
-            <a:ext cx="762000" cy="19050"/>
-          </a:xfrm>
-          <a:prstGeom xmlns:a="http://schemas.openxmlformats.org/drawingml/2006/main" prst="rect">
-            <a:avLst/>
-          </a:prstGeom>
-          <a:solidFill xmlns:a="http://schemas.openxmlformats.org/drawingml/2006/main">
-            <a:srgbClr val="A8A198"/>
-          </a:solidFill>
-          <a:ln xmlns:a="http://schemas.openxmlformats.org/drawingml/2006/main" w="0">
-            <a:solidFill>
-              <a:srgbClr val="A8A198"/>
-            </a:solidFill>
-            <a:prstDash val="solid"/>
-          </a:ln>
-        </p:spPr>
-        <p:txBody xmlns:a="http://schemas.openxmlformats.org/drawingml/2006/main">
-          <a:bodyPr/>
-          <a:p/>
-        </p:txBody>
-      </p:sp>
-      <p:sp>
-        <p:nvSpPr>
-          <p:cNvPr id="12" name="box-proposed operations">
-            <a:extLst xmlns:a="http://schemas.openxmlformats.org/drawingml/2006/main">
-              <a:ext uri="{FF2B5EF4-FFF2-40B4-BE49-F238E27FC236}">
-                <a16:creationId xmlns:a16="http://schemas.microsoft.com/office/drawing/2014/main" id="{50713F3E-2EA5-49A2-B283-FE6072CB55F5}"/>
-              </a:ext>
-            </a:extLst>
-          </p:cNvPr>
-          <p:cNvSpPr>
-            <a:spLocks xmlns:a="http://schemas.openxmlformats.org/drawingml/2006/main" noGrp="1"/>
-          </p:cNvSpPr>
-          <p:nvPr/>
-        </p:nvSpPr>
-        <p:spPr>
-          <a:xfrm xmlns:a="http://schemas.openxmlformats.org/drawingml/2006/main">
-            <a:off x="6610350" y="3790950"/>
-            <a:ext cx="2381250" cy="590550"/>
-          </a:xfrm>
-          <a:prstGeom xmlns:a="http://schemas.openxmlformats.org/drawingml/2006/main" prst="rect">
-            <a:avLst/>
-          </a:prstGeom>
-          <a:solidFill xmlns:a="http://schemas.openxmlformats.org/drawingml/2006/main">
-            <a:srgbClr val="DCE9EA"/>
-          </a:solidFill>
-          <a:ln xmlns:a="http://schemas.openxmlformats.org/drawingml/2006/main" w="11430">
-            <a:solidFill>
-              <a:srgbClr val="2F5F6F"/>
-            </a:solidFill>
-            <a:prstDash val="solid"/>
-          </a:ln>
-        </p:spPr>
-        <p:txBody xmlns:a="http://schemas.openxmlformats.org/drawingml/2006/main">
-          <a:bodyPr/>
-          <a:p/>
-        </p:txBody>
-      </p:sp>
-      <p:sp>
-        <p:nvSpPr>
-          <p:cNvPr id="13" name="label-proposed operations">
-            <a:extLst xmlns:a="http://schemas.openxmlformats.org/drawingml/2006/main">
-              <a:ext uri="{FF2B5EF4-FFF2-40B4-BE49-F238E27FC236}">
-                <a16:creationId xmlns:a16="http://schemas.microsoft.com/office/drawing/2014/main" id="{073909C2-E409-481D-AD0D-CA9FEC35B8A3}"/>
-              </a:ext>
-            </a:extLst>
-          </p:cNvPr>
-          <p:cNvSpPr>
-            <a:spLocks xmlns:a="http://schemas.openxmlformats.org/drawingml/2006/main" noGrp="1"/>
-          </p:cNvSpPr>
-          <p:nvPr/>
-        </p:nvSpPr>
-        <p:spPr>
-          <a:xfrm xmlns:a="http://schemas.openxmlformats.org/drawingml/2006/main">
-            <a:off x="6743700" y="3905250"/>
-            <a:ext cx="2114550" cy="361950"/>
-          </a:xfrm>
-          <a:prstGeom xmlns:a="http://schemas.openxmlformats.org/drawingml/2006/main" prst="rect">
-            <a:avLst/>
-          </a:prstGeom>
-          <a:solidFill xmlns:a="http://schemas.openxmlformats.org/drawingml/2006/main">
-            <a:srgbClr val="000000">
-              <a:alpha val="0"/>
-            </a:srgbClr>
-          </a:solidFill>
-          <a:ln xmlns:a="http://schemas.openxmlformats.org/drawingml/2006/main" w="0">
-            <a:solidFill>
-              <a:srgbClr val="000000">
-                <a:alpha val="0"/>
-              </a:srgbClr>
-            </a:solidFill>
-            <a:prstDash val="solid"/>
-          </a:ln>
-        </p:spPr>
-        <p:txBody>
-          <a:bodyPr xmlns:a="http://schemas.openxmlformats.org/drawingml/2006/main" lIns="0" tIns="0" rIns="0" bIns="0" anchor="ctr"/>
-          <a:lstStyle xmlns:a="http://schemas.openxmlformats.org/drawingml/2006/main"/>
-          <a:p xmlns:a="http://schemas.openxmlformats.org/drawingml/2006/main">
-            <a:pPr algn="ctr">
-              <a:defRPr sz="1125" b="1">
-                <a:solidFill>
-                  <a:srgbClr val="20262A"/>
-                </a:solidFill>
-                <a:latin typeface="Aptos"/>
-                <a:ea typeface="Aptos"/>
-                <a:cs typeface="Aptos"/>
-              </a:defRPr>
-            </a:pPr>
-            <a:r>
-              <a:rPr sz="1125" b="1">
-                <a:solidFill>
-                  <a:srgbClr val="20262A"/>
-                </a:solidFill>
-                <a:latin typeface="Aptos"/>
-                <a:ea typeface="Aptos"/>
-                <a:cs typeface="Aptos"/>
-              </a:rPr>
-              <a:t>proposed operations</a:t>
-            </a:r>
-          </a:p>
-        </p:txBody>
-      </p:sp>
-      <p:sp>
-        <p:nvSpPr>
-          <p:cNvPr id="14" name="line-h">
-            <a:extLst xmlns:a="http://schemas.openxmlformats.org/drawingml/2006/main">
-              <a:ext uri="{FF2B5EF4-FFF2-40B4-BE49-F238E27FC236}">
-                <a16:creationId xmlns:a16="http://schemas.microsoft.com/office/drawing/2014/main" id="{6A623131-72F4-489B-9CFD-F5920E53DDBF}"/>
-              </a:ext>
-            </a:extLst>
-          </p:cNvPr>
-          <p:cNvSpPr>
-            <a:spLocks xmlns:a="http://schemas.openxmlformats.org/drawingml/2006/main" noGrp="1"/>
-          </p:cNvSpPr>
-          <p:nvPr/>
-        </p:nvSpPr>
-        <p:spPr>
-          <a:xfrm xmlns:a="http://schemas.openxmlformats.org/drawingml/2006/main">
-            <a:off x="5848350" y="4086225"/>
-            <a:ext cx="762000" cy="19050"/>
-          </a:xfrm>
-          <a:prstGeom xmlns:a="http://schemas.openxmlformats.org/drawingml/2006/main" prst="rect">
-            <a:avLst/>
-          </a:prstGeom>
-          <a:solidFill xmlns:a="http://schemas.openxmlformats.org/drawingml/2006/main">
-            <a:srgbClr val="A8A198"/>
-          </a:solidFill>
-          <a:ln xmlns:a="http://schemas.openxmlformats.org/drawingml/2006/main" w="0">
-            <a:solidFill>
-              <a:srgbClr val="A8A198"/>
-            </a:solidFill>
-            <a:prstDash val="solid"/>
-          </a:ln>
-        </p:spPr>
-        <p:txBody xmlns:a="http://schemas.openxmlformats.org/drawingml/2006/main">
-          <a:bodyPr/>
-          <a:p/>
-        </p:txBody>
-      </p:sp>
-      <p:sp>
-        <p:nvSpPr>
-          <p:cNvPr id="15" name="box-reviewer decision">
-            <a:extLst xmlns:a="http://schemas.openxmlformats.org/drawingml/2006/main">
-              <a:ext uri="{FF2B5EF4-FFF2-40B4-BE49-F238E27FC236}">
-                <a16:creationId xmlns:a16="http://schemas.microsoft.com/office/drawing/2014/main" id="{30F82B85-F5F0-4561-A33E-BAD0A876D494}"/>
-              </a:ext>
-            </a:extLst>
-          </p:cNvPr>
-          <p:cNvSpPr>
-            <a:spLocks xmlns:a="http://schemas.openxmlformats.org/drawingml/2006/main" noGrp="1"/>
-          </p:cNvSpPr>
-          <p:nvPr/>
-        </p:nvSpPr>
-        <p:spPr>
-          <a:xfrm xmlns:a="http://schemas.openxmlformats.org/drawingml/2006/main">
-            <a:off x="9734550" y="3790950"/>
-            <a:ext cx="2095500" cy="590550"/>
-          </a:xfrm>
-          <a:prstGeom xmlns:a="http://schemas.openxmlformats.org/drawingml/2006/main" prst="rect">
-            <a:avLst/>
-          </a:prstGeom>
-          <a:solidFill xmlns:a="http://schemas.openxmlformats.org/drawingml/2006/main">
-            <a:srgbClr val="F7F6F1"/>
-          </a:solidFill>
-          <a:ln xmlns:a="http://schemas.openxmlformats.org/drawingml/2006/main" w="9525">
-            <a:solidFill>
-              <a:srgbClr val="E2DED4"/>
-            </a:solidFill>
-            <a:prstDash val="solid"/>
-          </a:ln>
-        </p:spPr>
-        <p:txBody xmlns:a="http://schemas.openxmlformats.org/drawingml/2006/main">
-          <a:bodyPr/>
-          <a:p/>
-        </p:txBody>
-      </p:sp>
-      <p:sp>
-        <p:nvSpPr>
-          <p:cNvPr id="16" name="label-reviewer decision">
-            <a:extLst xmlns:a="http://schemas.openxmlformats.org/drawingml/2006/main">
-              <a:ext uri="{FF2B5EF4-FFF2-40B4-BE49-F238E27FC236}">
-                <a16:creationId xmlns:a16="http://schemas.microsoft.com/office/drawing/2014/main" id="{D0FFFEBB-59AA-46E9-A616-0F2F4CF4F03F}"/>
-              </a:ext>
-            </a:extLst>
-          </p:cNvPr>
-          <p:cNvSpPr>
-            <a:spLocks xmlns:a="http://schemas.openxmlformats.org/drawingml/2006/main" noGrp="1"/>
-          </p:cNvSpPr>
-          <p:nvPr/>
-        </p:nvSpPr>
-        <p:spPr>
-          <a:xfrm xmlns:a="http://schemas.openxmlformats.org/drawingml/2006/main">
-            <a:off x="9867900" y="3905250"/>
-            <a:ext cx="1828800" cy="361950"/>
-          </a:xfrm>
-          <a:prstGeom xmlns:a="http://schemas.openxmlformats.org/drawingml/2006/main" prst="rect">
-            <a:avLst/>
-          </a:prstGeom>
-          <a:solidFill xmlns:a="http://schemas.openxmlformats.org/drawingml/2006/main">
-            <a:srgbClr val="000000">
-              <a:alpha val="0"/>
-            </a:srgbClr>
-          </a:solidFill>
-          <a:ln xmlns:a="http://schemas.openxmlformats.org/drawingml/2006/main" w="0">
-            <a:solidFill>
-              <a:srgbClr val="000000">
-                <a:alpha val="0"/>
-              </a:srgbClr>
-            </a:solidFill>
-            <a:prstDash val="solid"/>
-          </a:ln>
-        </p:spPr>
-        <p:txBody>
-          <a:bodyPr xmlns:a="http://schemas.openxmlformats.org/drawingml/2006/main" lIns="0" tIns="0" rIns="0" bIns="0" anchor="ctr"/>
-          <a:lstStyle xmlns:a="http://schemas.openxmlformats.org/drawingml/2006/main"/>
-          <a:p xmlns:a="http://schemas.openxmlformats.org/drawingml/2006/main">
-            <a:pPr algn="ctr">
-              <a:defRPr sz="1125" b="0">
-                <a:solidFill>
-                  <a:srgbClr val="697277"/>
-                </a:solidFill>
-                <a:latin typeface="Aptos"/>
-                <a:ea typeface="Aptos"/>
-                <a:cs typeface="Aptos"/>
-              </a:defRPr>
-            </a:pPr>
-            <a:r>
-              <a:rPr sz="1125" b="0">
-                <a:solidFill>
-                  <a:srgbClr val="697277"/>
-                </a:solidFill>
-                <a:latin typeface="Aptos"/>
-                <a:ea typeface="Aptos"/>
-                <a:cs typeface="Aptos"/>
-              </a:rPr>
-              <a:t>reviewer decision</a:t>
-            </a:r>
-          </a:p>
-        </p:txBody>
-      </p:sp>
-      <p:sp>
-        <p:nvSpPr>
-          <p:cNvPr id="17" name="">
-            <a:extLst xmlns:a="http://schemas.openxmlformats.org/drawingml/2006/main">
-              <a:ext uri="{FF2B5EF4-FFF2-40B4-BE49-F238E27FC236}">
-                <a16:creationId xmlns:a16="http://schemas.microsoft.com/office/drawing/2014/main" id="{B1B894F9-C554-48D2-8998-93AF795833C9}"/>
-              </a:ext>
-            </a:extLst>
-          </p:cNvPr>
-          <p:cNvSpPr>
-            <a:spLocks xmlns:a="http://schemas.openxmlformats.org/drawingml/2006/main" noGrp="1"/>
-          </p:cNvSpPr>
-          <p:nvPr/>
-        </p:nvSpPr>
-        <p:spPr>
-          <a:xfrm xmlns:a="http://schemas.openxmlformats.org/drawingml/2006/main">
-            <a:off x="6667500" y="4610100"/>
-            <a:ext cx="2286000" cy="704850"/>
-          </a:xfrm>
-          <a:prstGeom xmlns:a="http://schemas.openxmlformats.org/drawingml/2006/main" prst="rect">
-            <a:avLst/>
-          </a:prstGeom>
-          <a:solidFill xmlns:a="http://schemas.openxmlformats.org/drawingml/2006/main">
-            <a:srgbClr val="000000">
-              <a:alpha val="0"/>
-            </a:srgbClr>
-          </a:solidFill>
-          <a:ln xmlns:a="http://schemas.openxmlformats.org/drawingml/2006/main" w="0">
-            <a:solidFill>
-              <a:srgbClr val="000000">
-                <a:alpha val="0"/>
-              </a:srgbClr>
-            </a:solidFill>
-            <a:prstDash val="solid"/>
-          </a:ln>
-        </p:spPr>
-        <p:txBody>
-          <a:bodyPr xmlns:a="http://schemas.openxmlformats.org/drawingml/2006/main" lIns="0" tIns="0" rIns="0" bIns="0" anchor="ctr"/>
-          <a:lstStyle xmlns:a="http://schemas.openxmlformats.org/drawingml/2006/main"/>
-          <a:p xmlns:a="http://schemas.openxmlformats.org/drawingml/2006/main">
-            <a:pPr algn="ctr">
-              <a:defRPr sz="975" b="0">
-                <a:solidFill>
-                  <a:srgbClr val="697277"/>
-                </a:solidFill>
-                <a:latin typeface="Aptos"/>
-                <a:ea typeface="Aptos"/>
-                <a:cs typeface="Aptos"/>
-              </a:defRPr>
-            </a:pPr>
-            <a:r>
-              <a:rPr sz="975" b="0">
-                <a:solidFill>
-                  <a:srgbClr val="697277"/>
-                </a:solidFill>
-                <a:latin typeface="Aptos"/>
-                <a:ea typeface="Aptos"/>
-                <a:cs typeface="Aptos"/>
-              </a:rPr>
-              <a:t>link to question</a:t>
-            </a:r>
-          </a:p>
-          <a:p xmlns:a="http://schemas.openxmlformats.org/drawingml/2006/main">
-            <a:pPr algn="ctr">
-              <a:defRPr sz="975" b="0">
-                <a:solidFill>
-                  <a:srgbClr val="697277"/>
-                </a:solidFill>
-                <a:latin typeface="Aptos"/>
-                <a:ea typeface="Aptos"/>
-                <a:cs typeface="Aptos"/>
-              </a:defRPr>
-            </a:pPr>
-            <a:r>
-              <a:rPr sz="975" b="0">
-                <a:solidFill>
-                  <a:srgbClr val="697277"/>
-                </a:solidFill>
-                <a:latin typeface="Aptos"/>
-                <a:ea typeface="Aptos"/>
-                <a:cs typeface="Aptos"/>
-              </a:rPr>
-              <a:t>link dataset</a:t>
-            </a:r>
-          </a:p>
-          <a:p xmlns:a="http://schemas.openxmlformats.org/drawingml/2006/main">
-            <a:pPr algn="ctr">
-              <a:defRPr sz="975" b="0">
-                <a:solidFill>
-                  <a:srgbClr val="697277"/>
-                </a:solidFill>
-                <a:latin typeface="Aptos"/>
-                <a:ea typeface="Aptos"/>
-                <a:cs typeface="Aptos"/>
-              </a:defRPr>
-            </a:pPr>
-            <a:r>
-              <a:rPr sz="975" b="0">
-                <a:solidFill>
-                  <a:srgbClr val="697277"/>
-                </a:solidFill>
-                <a:latin typeface="Aptos"/>
-                <a:ea typeface="Aptos"/>
-                <a:cs typeface="Aptos"/>
-              </a:rPr>
-              <a:t>attach evidence</a:t>
-            </a:r>
-          </a:p>
-        </p:txBody>
-      </p:sp>
+      <p:pic xmlns:a="http://schemas.openxmlformats.org/drawingml/2006/main" xmlns:r="http://schemas.openxmlformats.org/officeDocument/2006/relationships">
+        <p:nvPicPr>
+          <p:cNvPr id="7" name="Picture 6" descr="capture-draft-op-link.png"/>
+          <p:cNvPicPr>
+            <a:picLocks noChangeAspect="1"/>
+          </p:cNvPicPr>
+          <p:nvPr/>
+        </p:nvPicPr>
+        <p:blipFill>
+          <a:blip r:embed="rId3"/>
+          <a:stretch>
+            <a:fillRect/>
+          </a:stretch>
+        </p:blipFill>
+        <p:spPr>
+          <a:xfrm>
+            <a:off x="3727859" y="2240280"/>
+            <a:ext cx="4705801" cy="3886200"/>
+          </a:xfrm>
+          <a:prstGeom prst="rect">
+            <a:avLst/>
+          </a:prstGeom>
+        </p:spPr>
+      </p:pic>
     </p:spTree>
     <p:extLst>
       <p:ext uri="{BB962C8B-B14F-4D97-AF65-F5344CB8AC3E}">
@@ -11197,631 +10253,30 @@
           </a:p>
         </p:txBody>
       </p:sp>
-      <p:sp>
-        <p:nvSpPr>
-          <p:cNvPr id="7" name="box-raw note">
-            <a:extLst xmlns:a="http://schemas.openxmlformats.org/drawingml/2006/main">
-              <a:ext uri="{FF2B5EF4-FFF2-40B4-BE49-F238E27FC236}">
-                <a16:creationId xmlns:a16="http://schemas.microsoft.com/office/drawing/2014/main" id="{DC29B2F6-F097-43F9-A046-D637BA43843F}"/>
-              </a:ext>
-            </a:extLst>
-          </p:cNvPr>
-          <p:cNvSpPr>
-            <a:spLocks xmlns:a="http://schemas.openxmlformats.org/drawingml/2006/main" noGrp="1"/>
-          </p:cNvSpPr>
-          <p:nvPr/>
-        </p:nvSpPr>
-        <p:spPr>
-          <a:xfrm xmlns:a="http://schemas.openxmlformats.org/drawingml/2006/main">
-            <a:off x="1009650" y="3790950"/>
-            <a:ext cx="1905000" cy="590550"/>
-          </a:xfrm>
-          <a:prstGeom xmlns:a="http://schemas.openxmlformats.org/drawingml/2006/main" prst="rect">
-            <a:avLst/>
-          </a:prstGeom>
-          <a:solidFill xmlns:a="http://schemas.openxmlformats.org/drawingml/2006/main">
-            <a:srgbClr val="FFFFFF"/>
-          </a:solidFill>
-          <a:ln xmlns:a="http://schemas.openxmlformats.org/drawingml/2006/main" w="11430">
-            <a:solidFill>
-              <a:srgbClr val="20262A"/>
-            </a:solidFill>
-            <a:prstDash val="solid"/>
-          </a:ln>
-        </p:spPr>
-        <p:txBody xmlns:a="http://schemas.openxmlformats.org/drawingml/2006/main">
-          <a:bodyPr/>
-          <a:p/>
-        </p:txBody>
-      </p:sp>
-      <p:sp>
-        <p:nvSpPr>
-          <p:cNvPr id="8" name="label-raw note">
-            <a:extLst xmlns:a="http://schemas.openxmlformats.org/drawingml/2006/main">
-              <a:ext uri="{FF2B5EF4-FFF2-40B4-BE49-F238E27FC236}">
-                <a16:creationId xmlns:a16="http://schemas.microsoft.com/office/drawing/2014/main" id="{4EE1718F-6BFC-4896-BE80-D6909BF30BB6}"/>
-              </a:ext>
-            </a:extLst>
-          </p:cNvPr>
-          <p:cNvSpPr>
-            <a:spLocks xmlns:a="http://schemas.openxmlformats.org/drawingml/2006/main" noGrp="1"/>
-          </p:cNvSpPr>
-          <p:nvPr/>
-        </p:nvSpPr>
-        <p:spPr>
-          <a:xfrm xmlns:a="http://schemas.openxmlformats.org/drawingml/2006/main">
-            <a:off x="1143000" y="3905250"/>
-            <a:ext cx="1638300" cy="361950"/>
-          </a:xfrm>
-          <a:prstGeom xmlns:a="http://schemas.openxmlformats.org/drawingml/2006/main" prst="rect">
-            <a:avLst/>
-          </a:prstGeom>
-          <a:solidFill xmlns:a="http://schemas.openxmlformats.org/drawingml/2006/main">
-            <a:srgbClr val="000000">
-              <a:alpha val="0"/>
-            </a:srgbClr>
-          </a:solidFill>
-          <a:ln xmlns:a="http://schemas.openxmlformats.org/drawingml/2006/main" w="0">
-            <a:solidFill>
-              <a:srgbClr val="000000">
-                <a:alpha val="0"/>
-              </a:srgbClr>
-            </a:solidFill>
-            <a:prstDash val="solid"/>
-          </a:ln>
-        </p:spPr>
-        <p:txBody>
-          <a:bodyPr xmlns:a="http://schemas.openxmlformats.org/drawingml/2006/main" lIns="0" tIns="0" rIns="0" bIns="0" anchor="ctr"/>
-          <a:lstStyle xmlns:a="http://schemas.openxmlformats.org/drawingml/2006/main"/>
-          <a:p xmlns:a="http://schemas.openxmlformats.org/drawingml/2006/main">
-            <a:pPr algn="ctr">
-              <a:defRPr sz="1125" b="0">
-                <a:solidFill>
-                  <a:srgbClr val="20262A"/>
-                </a:solidFill>
-                <a:latin typeface="Aptos"/>
-                <a:ea typeface="Aptos"/>
-                <a:cs typeface="Aptos"/>
-              </a:defRPr>
-            </a:pPr>
-            <a:r>
-              <a:rPr sz="1125" b="0">
-                <a:solidFill>
-                  <a:srgbClr val="20262A"/>
-                </a:solidFill>
-                <a:latin typeface="Aptos"/>
-                <a:ea typeface="Aptos"/>
-                <a:cs typeface="Aptos"/>
-              </a:rPr>
-              <a:t>raw note</a:t>
-            </a:r>
-          </a:p>
-        </p:txBody>
-      </p:sp>
-      <p:sp>
-        <p:nvSpPr>
-          <p:cNvPr id="9" name="box-context packet">
-            <a:extLst xmlns:a="http://schemas.openxmlformats.org/drawingml/2006/main">
-              <a:ext uri="{FF2B5EF4-FFF2-40B4-BE49-F238E27FC236}">
-                <a16:creationId xmlns:a16="http://schemas.microsoft.com/office/drawing/2014/main" id="{6F23399E-6540-4539-BB15-4CC42CA9189A}"/>
-              </a:ext>
-            </a:extLst>
-          </p:cNvPr>
-          <p:cNvSpPr>
-            <a:spLocks xmlns:a="http://schemas.openxmlformats.org/drawingml/2006/main" noGrp="1"/>
-          </p:cNvSpPr>
-          <p:nvPr/>
-        </p:nvSpPr>
-        <p:spPr>
-          <a:xfrm xmlns:a="http://schemas.openxmlformats.org/drawingml/2006/main">
-            <a:off x="3676650" y="3790950"/>
-            <a:ext cx="2171700" cy="590550"/>
-          </a:xfrm>
-          <a:prstGeom xmlns:a="http://schemas.openxmlformats.org/drawingml/2006/main" prst="rect">
-            <a:avLst/>
-          </a:prstGeom>
-          <a:solidFill xmlns:a="http://schemas.openxmlformats.org/drawingml/2006/main">
-            <a:srgbClr val="FFFFFF"/>
-          </a:solidFill>
-          <a:ln xmlns:a="http://schemas.openxmlformats.org/drawingml/2006/main" w="11430">
-            <a:solidFill>
-              <a:srgbClr val="20262A"/>
-            </a:solidFill>
-            <a:prstDash val="solid"/>
-          </a:ln>
-        </p:spPr>
-        <p:txBody xmlns:a="http://schemas.openxmlformats.org/drawingml/2006/main">
-          <a:bodyPr/>
-          <a:p/>
-        </p:txBody>
-      </p:sp>
-      <p:sp>
-        <p:nvSpPr>
-          <p:cNvPr id="10" name="label-context packet">
-            <a:extLst xmlns:a="http://schemas.openxmlformats.org/drawingml/2006/main">
-              <a:ext uri="{FF2B5EF4-FFF2-40B4-BE49-F238E27FC236}">
-                <a16:creationId xmlns:a16="http://schemas.microsoft.com/office/drawing/2014/main" id="{2987A798-8517-40FC-8A51-2438493CF853}"/>
-              </a:ext>
-            </a:extLst>
-          </p:cNvPr>
-          <p:cNvSpPr>
-            <a:spLocks xmlns:a="http://schemas.openxmlformats.org/drawingml/2006/main" noGrp="1"/>
-          </p:cNvSpPr>
-          <p:nvPr/>
-        </p:nvSpPr>
-        <p:spPr>
-          <a:xfrm xmlns:a="http://schemas.openxmlformats.org/drawingml/2006/main">
-            <a:off x="3810000" y="3905250"/>
-            <a:ext cx="1905000" cy="361950"/>
-          </a:xfrm>
-          <a:prstGeom xmlns:a="http://schemas.openxmlformats.org/drawingml/2006/main" prst="rect">
-            <a:avLst/>
-          </a:prstGeom>
-          <a:solidFill xmlns:a="http://schemas.openxmlformats.org/drawingml/2006/main">
-            <a:srgbClr val="000000">
-              <a:alpha val="0"/>
-            </a:srgbClr>
-          </a:solidFill>
-          <a:ln xmlns:a="http://schemas.openxmlformats.org/drawingml/2006/main" w="0">
-            <a:solidFill>
-              <a:srgbClr val="000000">
-                <a:alpha val="0"/>
-              </a:srgbClr>
-            </a:solidFill>
-            <a:prstDash val="solid"/>
-          </a:ln>
-        </p:spPr>
-        <p:txBody>
-          <a:bodyPr xmlns:a="http://schemas.openxmlformats.org/drawingml/2006/main" lIns="0" tIns="0" rIns="0" bIns="0" anchor="ctr"/>
-          <a:lstStyle xmlns:a="http://schemas.openxmlformats.org/drawingml/2006/main"/>
-          <a:p xmlns:a="http://schemas.openxmlformats.org/drawingml/2006/main">
-            <a:pPr algn="ctr">
-              <a:defRPr sz="1125" b="0">
-                <a:solidFill>
-                  <a:srgbClr val="20262A"/>
-                </a:solidFill>
-                <a:latin typeface="Aptos"/>
-                <a:ea typeface="Aptos"/>
-                <a:cs typeface="Aptos"/>
-              </a:defRPr>
-            </a:pPr>
-            <a:r>
-              <a:rPr sz="1125" b="0">
-                <a:solidFill>
-                  <a:srgbClr val="20262A"/>
-                </a:solidFill>
-                <a:latin typeface="Aptos"/>
-                <a:ea typeface="Aptos"/>
-                <a:cs typeface="Aptos"/>
-              </a:rPr>
-              <a:t>context packet</a:t>
-            </a:r>
-          </a:p>
-        </p:txBody>
-      </p:sp>
-      <p:sp>
-        <p:nvSpPr>
-          <p:cNvPr id="11" name="line-h">
-            <a:extLst xmlns:a="http://schemas.openxmlformats.org/drawingml/2006/main">
-              <a:ext uri="{FF2B5EF4-FFF2-40B4-BE49-F238E27FC236}">
-                <a16:creationId xmlns:a16="http://schemas.microsoft.com/office/drawing/2014/main" id="{98BB1A91-FA55-4F80-8A9E-4F532E6730E6}"/>
-              </a:ext>
-            </a:extLst>
-          </p:cNvPr>
-          <p:cNvSpPr>
-            <a:spLocks xmlns:a="http://schemas.openxmlformats.org/drawingml/2006/main" noGrp="1"/>
-          </p:cNvSpPr>
-          <p:nvPr/>
-        </p:nvSpPr>
-        <p:spPr>
-          <a:xfrm xmlns:a="http://schemas.openxmlformats.org/drawingml/2006/main">
-            <a:off x="2914650" y="4086225"/>
-            <a:ext cx="762000" cy="19050"/>
-          </a:xfrm>
-          <a:prstGeom xmlns:a="http://schemas.openxmlformats.org/drawingml/2006/main" prst="rect">
-            <a:avLst/>
-          </a:prstGeom>
-          <a:solidFill xmlns:a="http://schemas.openxmlformats.org/drawingml/2006/main">
-            <a:srgbClr val="A8A198"/>
-          </a:solidFill>
-          <a:ln xmlns:a="http://schemas.openxmlformats.org/drawingml/2006/main" w="0">
-            <a:solidFill>
-              <a:srgbClr val="A8A198"/>
-            </a:solidFill>
-            <a:prstDash val="solid"/>
-          </a:ln>
-        </p:spPr>
-        <p:txBody xmlns:a="http://schemas.openxmlformats.org/drawingml/2006/main">
-          <a:bodyPr/>
-          <a:p/>
-        </p:txBody>
-      </p:sp>
-      <p:sp>
-        <p:nvSpPr>
-          <p:cNvPr id="12" name="box-proposed operations">
-            <a:extLst xmlns:a="http://schemas.openxmlformats.org/drawingml/2006/main">
-              <a:ext uri="{FF2B5EF4-FFF2-40B4-BE49-F238E27FC236}">
-                <a16:creationId xmlns:a16="http://schemas.microsoft.com/office/drawing/2014/main" id="{99935A6B-9F5E-4D65-928D-8BFF2CDC2CE7}"/>
-              </a:ext>
-            </a:extLst>
-          </p:cNvPr>
-          <p:cNvSpPr>
-            <a:spLocks xmlns:a="http://schemas.openxmlformats.org/drawingml/2006/main" noGrp="1"/>
-          </p:cNvSpPr>
-          <p:nvPr/>
-        </p:nvSpPr>
-        <p:spPr>
-          <a:xfrm xmlns:a="http://schemas.openxmlformats.org/drawingml/2006/main">
-            <a:off x="6610350" y="3790950"/>
-            <a:ext cx="2381250" cy="590550"/>
-          </a:xfrm>
-          <a:prstGeom xmlns:a="http://schemas.openxmlformats.org/drawingml/2006/main" prst="rect">
-            <a:avLst/>
-          </a:prstGeom>
-          <a:solidFill xmlns:a="http://schemas.openxmlformats.org/drawingml/2006/main">
-            <a:srgbClr val="FFFFFF"/>
-          </a:solidFill>
-          <a:ln xmlns:a="http://schemas.openxmlformats.org/drawingml/2006/main" w="11430">
-            <a:solidFill>
-              <a:srgbClr val="20262A"/>
-            </a:solidFill>
-            <a:prstDash val="solid"/>
-          </a:ln>
-        </p:spPr>
-        <p:txBody xmlns:a="http://schemas.openxmlformats.org/drawingml/2006/main">
-          <a:bodyPr/>
-          <a:p/>
-        </p:txBody>
-      </p:sp>
-      <p:sp>
-        <p:nvSpPr>
-          <p:cNvPr id="13" name="label-proposed operations">
-            <a:extLst xmlns:a="http://schemas.openxmlformats.org/drawingml/2006/main">
-              <a:ext uri="{FF2B5EF4-FFF2-40B4-BE49-F238E27FC236}">
-                <a16:creationId xmlns:a16="http://schemas.microsoft.com/office/drawing/2014/main" id="{AE5BAA01-79E6-4E99-B967-CCF2DFBE713C}"/>
-              </a:ext>
-            </a:extLst>
-          </p:cNvPr>
-          <p:cNvSpPr>
-            <a:spLocks xmlns:a="http://schemas.openxmlformats.org/drawingml/2006/main" noGrp="1"/>
-          </p:cNvSpPr>
-          <p:nvPr/>
-        </p:nvSpPr>
-        <p:spPr>
-          <a:xfrm xmlns:a="http://schemas.openxmlformats.org/drawingml/2006/main">
-            <a:off x="6743700" y="3905250"/>
-            <a:ext cx="2114550" cy="361950"/>
-          </a:xfrm>
-          <a:prstGeom xmlns:a="http://schemas.openxmlformats.org/drawingml/2006/main" prst="rect">
-            <a:avLst/>
-          </a:prstGeom>
-          <a:solidFill xmlns:a="http://schemas.openxmlformats.org/drawingml/2006/main">
-            <a:srgbClr val="000000">
-              <a:alpha val="0"/>
-            </a:srgbClr>
-          </a:solidFill>
-          <a:ln xmlns:a="http://schemas.openxmlformats.org/drawingml/2006/main" w="0">
-            <a:solidFill>
-              <a:srgbClr val="000000">
-                <a:alpha val="0"/>
-              </a:srgbClr>
-            </a:solidFill>
-            <a:prstDash val="solid"/>
-          </a:ln>
-        </p:spPr>
-        <p:txBody>
-          <a:bodyPr xmlns:a="http://schemas.openxmlformats.org/drawingml/2006/main" lIns="0" tIns="0" rIns="0" bIns="0" anchor="ctr"/>
-          <a:lstStyle xmlns:a="http://schemas.openxmlformats.org/drawingml/2006/main"/>
-          <a:p xmlns:a="http://schemas.openxmlformats.org/drawingml/2006/main">
-            <a:pPr algn="ctr">
-              <a:defRPr sz="1125" b="0">
-                <a:solidFill>
-                  <a:srgbClr val="20262A"/>
-                </a:solidFill>
-                <a:latin typeface="Aptos"/>
-                <a:ea typeface="Aptos"/>
-                <a:cs typeface="Aptos"/>
-              </a:defRPr>
-            </a:pPr>
-            <a:r>
-              <a:rPr sz="1125" b="0">
-                <a:solidFill>
-                  <a:srgbClr val="20262A"/>
-                </a:solidFill>
-                <a:latin typeface="Aptos"/>
-                <a:ea typeface="Aptos"/>
-                <a:cs typeface="Aptos"/>
-              </a:rPr>
-              <a:t>proposed operations</a:t>
-            </a:r>
-          </a:p>
-        </p:txBody>
-      </p:sp>
-      <p:sp>
-        <p:nvSpPr>
-          <p:cNvPr id="14" name="line-h">
-            <a:extLst xmlns:a="http://schemas.openxmlformats.org/drawingml/2006/main">
-              <a:ext uri="{FF2B5EF4-FFF2-40B4-BE49-F238E27FC236}">
-                <a16:creationId xmlns:a16="http://schemas.microsoft.com/office/drawing/2014/main" id="{D487D970-5EA9-4B37-B7A4-B9A937615715}"/>
-              </a:ext>
-            </a:extLst>
-          </p:cNvPr>
-          <p:cNvSpPr>
-            <a:spLocks xmlns:a="http://schemas.openxmlformats.org/drawingml/2006/main" noGrp="1"/>
-          </p:cNvSpPr>
-          <p:nvPr/>
-        </p:nvSpPr>
-        <p:spPr>
-          <a:xfrm xmlns:a="http://schemas.openxmlformats.org/drawingml/2006/main">
-            <a:off x="5848350" y="4086225"/>
-            <a:ext cx="762000" cy="19050"/>
-          </a:xfrm>
-          <a:prstGeom xmlns:a="http://schemas.openxmlformats.org/drawingml/2006/main" prst="rect">
-            <a:avLst/>
-          </a:prstGeom>
-          <a:solidFill xmlns:a="http://schemas.openxmlformats.org/drawingml/2006/main">
-            <a:srgbClr val="A8A198"/>
-          </a:solidFill>
-          <a:ln xmlns:a="http://schemas.openxmlformats.org/drawingml/2006/main" w="0">
-            <a:solidFill>
-              <a:srgbClr val="A8A198"/>
-            </a:solidFill>
-            <a:prstDash val="solid"/>
-          </a:ln>
-        </p:spPr>
-        <p:txBody xmlns:a="http://schemas.openxmlformats.org/drawingml/2006/main">
-          <a:bodyPr/>
-          <a:p/>
-        </p:txBody>
-      </p:sp>
-      <p:sp>
-        <p:nvSpPr>
-          <p:cNvPr id="15" name="box-reviewer decision">
-            <a:extLst xmlns:a="http://schemas.openxmlformats.org/drawingml/2006/main">
-              <a:ext uri="{FF2B5EF4-FFF2-40B4-BE49-F238E27FC236}">
-                <a16:creationId xmlns:a16="http://schemas.microsoft.com/office/drawing/2014/main" id="{02B6BCBE-EB64-4A0A-A61C-192A473B4082}"/>
-              </a:ext>
-            </a:extLst>
-          </p:cNvPr>
-          <p:cNvSpPr>
-            <a:spLocks xmlns:a="http://schemas.openxmlformats.org/drawingml/2006/main" noGrp="1"/>
-          </p:cNvSpPr>
-          <p:nvPr/>
-        </p:nvSpPr>
-        <p:spPr>
-          <a:xfrm xmlns:a="http://schemas.openxmlformats.org/drawingml/2006/main">
-            <a:off x="9734550" y="3790950"/>
-            <a:ext cx="2095500" cy="590550"/>
-          </a:xfrm>
-          <a:prstGeom xmlns:a="http://schemas.openxmlformats.org/drawingml/2006/main" prst="rect">
-            <a:avLst/>
-          </a:prstGeom>
-          <a:solidFill xmlns:a="http://schemas.openxmlformats.org/drawingml/2006/main">
-            <a:srgbClr val="DCE9EA"/>
-          </a:solidFill>
-          <a:ln xmlns:a="http://schemas.openxmlformats.org/drawingml/2006/main" w="11430">
-            <a:solidFill>
-              <a:srgbClr val="2F5F6F"/>
-            </a:solidFill>
-            <a:prstDash val="solid"/>
-          </a:ln>
-        </p:spPr>
-        <p:txBody xmlns:a="http://schemas.openxmlformats.org/drawingml/2006/main">
-          <a:bodyPr/>
-          <a:p/>
-        </p:txBody>
-      </p:sp>
-      <p:sp>
-        <p:nvSpPr>
-          <p:cNvPr id="16" name="label-reviewer decision">
-            <a:extLst xmlns:a="http://schemas.openxmlformats.org/drawingml/2006/main">
-              <a:ext uri="{FF2B5EF4-FFF2-40B4-BE49-F238E27FC236}">
-                <a16:creationId xmlns:a16="http://schemas.microsoft.com/office/drawing/2014/main" id="{F78A1A20-18D3-4E9E-A4A7-8EA9302CC4B0}"/>
-              </a:ext>
-            </a:extLst>
-          </p:cNvPr>
-          <p:cNvSpPr>
-            <a:spLocks xmlns:a="http://schemas.openxmlformats.org/drawingml/2006/main" noGrp="1"/>
-          </p:cNvSpPr>
-          <p:nvPr/>
-        </p:nvSpPr>
-        <p:spPr>
-          <a:xfrm xmlns:a="http://schemas.openxmlformats.org/drawingml/2006/main">
-            <a:off x="9867900" y="3905250"/>
-            <a:ext cx="1828800" cy="361950"/>
-          </a:xfrm>
-          <a:prstGeom xmlns:a="http://schemas.openxmlformats.org/drawingml/2006/main" prst="rect">
-            <a:avLst/>
-          </a:prstGeom>
-          <a:solidFill xmlns:a="http://schemas.openxmlformats.org/drawingml/2006/main">
-            <a:srgbClr val="000000">
-              <a:alpha val="0"/>
-            </a:srgbClr>
-          </a:solidFill>
-          <a:ln xmlns:a="http://schemas.openxmlformats.org/drawingml/2006/main" w="0">
-            <a:solidFill>
-              <a:srgbClr val="000000">
-                <a:alpha val="0"/>
-              </a:srgbClr>
-            </a:solidFill>
-            <a:prstDash val="solid"/>
-          </a:ln>
-        </p:spPr>
-        <p:txBody>
-          <a:bodyPr xmlns:a="http://schemas.openxmlformats.org/drawingml/2006/main" lIns="0" tIns="0" rIns="0" bIns="0" anchor="ctr"/>
-          <a:lstStyle xmlns:a="http://schemas.openxmlformats.org/drawingml/2006/main"/>
-          <a:p xmlns:a="http://schemas.openxmlformats.org/drawingml/2006/main">
-            <a:pPr algn="ctr">
-              <a:defRPr sz="1125" b="1">
-                <a:solidFill>
-                  <a:srgbClr val="20262A"/>
-                </a:solidFill>
-                <a:latin typeface="Aptos"/>
-                <a:ea typeface="Aptos"/>
-                <a:cs typeface="Aptos"/>
-              </a:defRPr>
-            </a:pPr>
-            <a:r>
-              <a:rPr sz="1125" b="1">
-                <a:solidFill>
-                  <a:srgbClr val="20262A"/>
-                </a:solidFill>
-                <a:latin typeface="Aptos"/>
-                <a:ea typeface="Aptos"/>
-                <a:cs typeface="Aptos"/>
-              </a:rPr>
-              <a:t>reviewer decision</a:t>
-            </a:r>
-          </a:p>
-        </p:txBody>
-      </p:sp>
-      <p:sp>
-        <p:nvSpPr>
-          <p:cNvPr id="17" name="line-h">
-            <a:extLst xmlns:a="http://schemas.openxmlformats.org/drawingml/2006/main">
-              <a:ext uri="{FF2B5EF4-FFF2-40B4-BE49-F238E27FC236}">
-                <a16:creationId xmlns:a16="http://schemas.microsoft.com/office/drawing/2014/main" id="{8DF49BBE-1A39-4CAF-872D-1C44A0A65239}"/>
-              </a:ext>
-            </a:extLst>
-          </p:cNvPr>
-          <p:cNvSpPr>
-            <a:spLocks xmlns:a="http://schemas.openxmlformats.org/drawingml/2006/main" noGrp="1"/>
-          </p:cNvSpPr>
-          <p:nvPr/>
-        </p:nvSpPr>
-        <p:spPr>
-          <a:xfrm xmlns:a="http://schemas.openxmlformats.org/drawingml/2006/main">
-            <a:off x="8991600" y="4086225"/>
-            <a:ext cx="742950" cy="19050"/>
-          </a:xfrm>
-          <a:prstGeom xmlns:a="http://schemas.openxmlformats.org/drawingml/2006/main" prst="rect">
-            <a:avLst/>
-          </a:prstGeom>
-          <a:solidFill xmlns:a="http://schemas.openxmlformats.org/drawingml/2006/main">
-            <a:srgbClr val="A8A198"/>
-          </a:solidFill>
-          <a:ln xmlns:a="http://schemas.openxmlformats.org/drawingml/2006/main" w="0">
-            <a:solidFill>
-              <a:srgbClr val="A8A198"/>
-            </a:solidFill>
-            <a:prstDash val="solid"/>
-          </a:ln>
-        </p:spPr>
-        <p:txBody xmlns:a="http://schemas.openxmlformats.org/drawingml/2006/main">
-          <a:bodyPr/>
-          <a:p/>
-        </p:txBody>
-      </p:sp>
-      <p:sp>
-        <p:nvSpPr>
-          <p:cNvPr id="18" name="">
-            <a:extLst xmlns:a="http://schemas.openxmlformats.org/drawingml/2006/main">
-              <a:ext uri="{FF2B5EF4-FFF2-40B4-BE49-F238E27FC236}">
-                <a16:creationId xmlns:a16="http://schemas.microsoft.com/office/drawing/2014/main" id="{7B6C8A8E-1BC9-4327-B2E0-163D455EBC71}"/>
-              </a:ext>
-            </a:extLst>
-          </p:cNvPr>
-          <p:cNvSpPr>
-            <a:spLocks xmlns:a="http://schemas.openxmlformats.org/drawingml/2006/main" noGrp="1"/>
-          </p:cNvSpPr>
-          <p:nvPr/>
-        </p:nvSpPr>
-        <p:spPr>
-          <a:xfrm xmlns:a="http://schemas.openxmlformats.org/drawingml/2006/main">
-            <a:off x="6667500" y="4610100"/>
-            <a:ext cx="2286000" cy="704850"/>
-          </a:xfrm>
-          <a:prstGeom xmlns:a="http://schemas.openxmlformats.org/drawingml/2006/main" prst="rect">
-            <a:avLst/>
-          </a:prstGeom>
-          <a:solidFill xmlns:a="http://schemas.openxmlformats.org/drawingml/2006/main">
-            <a:srgbClr val="000000">
-              <a:alpha val="0"/>
-            </a:srgbClr>
-          </a:solidFill>
-          <a:ln xmlns:a="http://schemas.openxmlformats.org/drawingml/2006/main" w="0">
-            <a:solidFill>
-              <a:srgbClr val="000000">
-                <a:alpha val="0"/>
-              </a:srgbClr>
-            </a:solidFill>
-            <a:prstDash val="solid"/>
-          </a:ln>
-        </p:spPr>
-        <p:txBody>
-          <a:bodyPr xmlns:a="http://schemas.openxmlformats.org/drawingml/2006/main" lIns="0" tIns="0" rIns="0" bIns="0" anchor="ctr"/>
-          <a:lstStyle xmlns:a="http://schemas.openxmlformats.org/drawingml/2006/main"/>
-          <a:p xmlns:a="http://schemas.openxmlformats.org/drawingml/2006/main">
-            <a:pPr algn="ctr">
-              <a:defRPr sz="975" b="0">
-                <a:solidFill>
-                  <a:srgbClr val="697277"/>
-                </a:solidFill>
-                <a:latin typeface="Aptos"/>
-                <a:ea typeface="Aptos"/>
-                <a:cs typeface="Aptos"/>
-              </a:defRPr>
-            </a:pPr>
-            <a:r>
-              <a:rPr sz="975" b="0">
-                <a:solidFill>
-                  <a:srgbClr val="697277"/>
-                </a:solidFill>
-                <a:latin typeface="Aptos"/>
-                <a:ea typeface="Aptos"/>
-                <a:cs typeface="Aptos"/>
-              </a:rPr>
-              <a:t>link to question</a:t>
-            </a:r>
-          </a:p>
-          <a:p xmlns:a="http://schemas.openxmlformats.org/drawingml/2006/main">
-            <a:pPr algn="ctr">
-              <a:defRPr sz="975" b="0">
-                <a:solidFill>
-                  <a:srgbClr val="697277"/>
-                </a:solidFill>
-                <a:latin typeface="Aptos"/>
-                <a:ea typeface="Aptos"/>
-                <a:cs typeface="Aptos"/>
-              </a:defRPr>
-            </a:pPr>
-            <a:r>
-              <a:rPr sz="975" b="0">
-                <a:solidFill>
-                  <a:srgbClr val="697277"/>
-                </a:solidFill>
-                <a:latin typeface="Aptos"/>
-                <a:ea typeface="Aptos"/>
-                <a:cs typeface="Aptos"/>
-              </a:rPr>
-              <a:t>link dataset</a:t>
-            </a:r>
-          </a:p>
-          <a:p xmlns:a="http://schemas.openxmlformats.org/drawingml/2006/main">
-            <a:pPr algn="ctr">
-              <a:defRPr sz="975" b="0">
-                <a:solidFill>
-                  <a:srgbClr val="697277"/>
-                </a:solidFill>
-                <a:latin typeface="Aptos"/>
-                <a:ea typeface="Aptos"/>
-                <a:cs typeface="Aptos"/>
-              </a:defRPr>
-            </a:pPr>
-            <a:r>
-              <a:rPr sz="975" b="0">
-                <a:solidFill>
-                  <a:srgbClr val="697277"/>
-                </a:solidFill>
-                <a:latin typeface="Aptos"/>
-                <a:ea typeface="Aptos"/>
-                <a:cs typeface="Aptos"/>
-              </a:rPr>
-              <a:t>attach evidence</a:t>
-            </a:r>
-          </a:p>
-        </p:txBody>
-      </p:sp>
+      <p:pic xmlns:a="http://schemas.openxmlformats.org/drawingml/2006/main" xmlns:r="http://schemas.openxmlformats.org/officeDocument/2006/relationships">
+        <p:nvPicPr>
+          <p:cNvPr id="7" name="Picture 6" descr="capture-draft-op-evidence.png"/>
+          <p:cNvPicPr>
+            <a:picLocks noChangeAspect="1"/>
+          </p:cNvPicPr>
+          <p:nvPr/>
+        </p:nvPicPr>
+        <p:blipFill>
+          <a:blip r:embed="rId3"/>
+          <a:stretch>
+            <a:fillRect/>
+          </a:stretch>
+        </p:blipFill>
+        <p:spPr>
+          <a:xfrm>
+            <a:off x="3411609" y="2240280"/>
+            <a:ext cx="5338301" cy="3886200"/>
+          </a:xfrm>
+          <a:prstGeom prst="rect">
+            <a:avLst/>
+          </a:prstGeom>
+        </p:spPr>
+      </p:pic>
     </p:spTree>
     <p:extLst>
       <p:ext uri="{BB962C8B-B14F-4D97-AF65-F5344CB8AC3E}">
@@ -12172,441 +10627,30 @@
           </a:p>
         </p:txBody>
       </p:sp>
-      <p:sp>
-        <p:nvSpPr>
-          <p:cNvPr id="7" name="box-one project">
-            <a:extLst xmlns:a="http://schemas.openxmlformats.org/drawingml/2006/main">
-              <a:ext uri="{FF2B5EF4-FFF2-40B4-BE49-F238E27FC236}">
-                <a16:creationId xmlns:a16="http://schemas.microsoft.com/office/drawing/2014/main" id="{AC3FB2D1-6BED-4EA3-A624-9C7654067886}"/>
-              </a:ext>
-            </a:extLst>
-          </p:cNvPr>
-          <p:cNvSpPr>
-            <a:spLocks xmlns:a="http://schemas.openxmlformats.org/drawingml/2006/main" noGrp="1"/>
-          </p:cNvSpPr>
-          <p:nvPr/>
-        </p:nvSpPr>
-        <p:spPr>
-          <a:xfrm xmlns:a="http://schemas.openxmlformats.org/drawingml/2006/main">
-            <a:off x="1676400" y="3543300"/>
-            <a:ext cx="2266950" cy="647700"/>
-          </a:xfrm>
-          <a:prstGeom xmlns:a="http://schemas.openxmlformats.org/drawingml/2006/main" prst="rect">
-            <a:avLst/>
-          </a:prstGeom>
-          <a:solidFill xmlns:a="http://schemas.openxmlformats.org/drawingml/2006/main">
-            <a:srgbClr val="FFFFFF"/>
-          </a:solidFill>
-          <a:ln xmlns:a="http://schemas.openxmlformats.org/drawingml/2006/main" w="11430">
-            <a:solidFill>
-              <a:srgbClr val="20262A"/>
-            </a:solidFill>
-            <a:prstDash val="solid"/>
-          </a:ln>
-        </p:spPr>
-        <p:txBody xmlns:a="http://schemas.openxmlformats.org/drawingml/2006/main">
-          <a:bodyPr/>
-          <a:p/>
-        </p:txBody>
-      </p:sp>
-      <p:sp>
-        <p:nvSpPr>
-          <p:cNvPr id="8" name="label-one project">
-            <a:extLst xmlns:a="http://schemas.openxmlformats.org/drawingml/2006/main">
-              <a:ext uri="{FF2B5EF4-FFF2-40B4-BE49-F238E27FC236}">
-                <a16:creationId xmlns:a16="http://schemas.microsoft.com/office/drawing/2014/main" id="{47D5E28D-33BB-4E85-BD66-A7834F7F5184}"/>
-              </a:ext>
-            </a:extLst>
-          </p:cNvPr>
-          <p:cNvSpPr>
-            <a:spLocks xmlns:a="http://schemas.openxmlformats.org/drawingml/2006/main" noGrp="1"/>
-          </p:cNvSpPr>
-          <p:nvPr/>
-        </p:nvSpPr>
-        <p:spPr>
-          <a:xfrm xmlns:a="http://schemas.openxmlformats.org/drawingml/2006/main">
-            <a:off x="1809750" y="3657600"/>
-            <a:ext cx="2000250" cy="419100"/>
-          </a:xfrm>
-          <a:prstGeom xmlns:a="http://schemas.openxmlformats.org/drawingml/2006/main" prst="rect">
-            <a:avLst/>
-          </a:prstGeom>
-          <a:solidFill xmlns:a="http://schemas.openxmlformats.org/drawingml/2006/main">
-            <a:srgbClr val="000000">
-              <a:alpha val="0"/>
-            </a:srgbClr>
-          </a:solidFill>
-          <a:ln xmlns:a="http://schemas.openxmlformats.org/drawingml/2006/main" w="0">
-            <a:solidFill>
-              <a:srgbClr val="000000">
-                <a:alpha val="0"/>
-              </a:srgbClr>
-            </a:solidFill>
-            <a:prstDash val="solid"/>
-          </a:ln>
-        </p:spPr>
-        <p:txBody>
-          <a:bodyPr xmlns:a="http://schemas.openxmlformats.org/drawingml/2006/main" lIns="0" tIns="0" rIns="0" bIns="0" anchor="ctr" wrap="square"/>
-          <a:lstStyle xmlns:a="http://schemas.openxmlformats.org/drawingml/2006/main"/>
-          <a:p xmlns:a="http://schemas.openxmlformats.org/drawingml/2006/main">
-            <a:pPr algn="ctr">
-              <a:defRPr sz="1050" b="0">
-                <a:solidFill>
-                  <a:srgbClr val="20262A"/>
-                </a:solidFill>
-                <a:latin typeface="Aptos"/>
-                <a:ea typeface="Aptos"/>
-                <a:cs typeface="Aptos"/>
-              </a:defRPr>
-            </a:pPr>
-            <a:r>
-              <a:rPr sz="1050" b="0">
-                <a:solidFill>
-                  <a:srgbClr val="20262A"/>
-                </a:solidFill>
-                <a:latin typeface="Aptos"/>
-              </a:rPr>
-              <a:t>AL-gain project</a:t>
-            </a:r>
-          </a:p>
-        </p:txBody>
-      </p:sp>
-      <p:sp>
-        <p:nvSpPr>
-          <p:cNvPr id="9" name="box-question hierarchy">
-            <a:extLst xmlns:a="http://schemas.openxmlformats.org/drawingml/2006/main">
-              <a:ext uri="{FF2B5EF4-FFF2-40B4-BE49-F238E27FC236}">
-                <a16:creationId xmlns:a16="http://schemas.microsoft.com/office/drawing/2014/main" id="{603BF524-4E71-4606-97C5-888D224414E2}"/>
-              </a:ext>
-            </a:extLst>
-          </p:cNvPr>
-          <p:cNvSpPr>
-            <a:spLocks xmlns:a="http://schemas.openxmlformats.org/drawingml/2006/main" noGrp="1"/>
-          </p:cNvSpPr>
-          <p:nvPr/>
-        </p:nvSpPr>
-        <p:spPr>
-          <a:xfrm xmlns:a="http://schemas.openxmlformats.org/drawingml/2006/main">
-            <a:off x="4667250" y="3543300"/>
-            <a:ext cx="2647950" cy="647700"/>
-          </a:xfrm>
-          <a:prstGeom xmlns:a="http://schemas.openxmlformats.org/drawingml/2006/main" prst="rect">
-            <a:avLst/>
-          </a:prstGeom>
-          <a:solidFill xmlns:a="http://schemas.openxmlformats.org/drawingml/2006/main">
-            <a:srgbClr val="DCE9EA"/>
-          </a:solidFill>
-          <a:ln xmlns:a="http://schemas.openxmlformats.org/drawingml/2006/main" w="11430">
-            <a:solidFill>
-              <a:srgbClr val="2F5F6F"/>
-            </a:solidFill>
-            <a:prstDash val="solid"/>
-          </a:ln>
-        </p:spPr>
-        <p:txBody xmlns:a="http://schemas.openxmlformats.org/drawingml/2006/main">
-          <a:bodyPr/>
-          <a:p/>
-        </p:txBody>
-      </p:sp>
-      <p:sp>
-        <p:nvSpPr>
-          <p:cNvPr id="10" name="label-question hierarchy">
-            <a:extLst xmlns:a="http://schemas.openxmlformats.org/drawingml/2006/main">
-              <a:ext uri="{FF2B5EF4-FFF2-40B4-BE49-F238E27FC236}">
-                <a16:creationId xmlns:a16="http://schemas.microsoft.com/office/drawing/2014/main" id="{9F636DD0-6B0C-4C7B-8049-40D5ABCFEE2F}"/>
-              </a:ext>
-            </a:extLst>
-          </p:cNvPr>
-          <p:cNvSpPr>
-            <a:spLocks xmlns:a="http://schemas.openxmlformats.org/drawingml/2006/main" noGrp="1"/>
-          </p:cNvSpPr>
-          <p:nvPr/>
-        </p:nvSpPr>
-        <p:spPr>
-          <a:xfrm xmlns:a="http://schemas.openxmlformats.org/drawingml/2006/main">
-            <a:off x="4800600" y="3657600"/>
-            <a:ext cx="2381250" cy="419100"/>
-          </a:xfrm>
-          <a:prstGeom xmlns:a="http://schemas.openxmlformats.org/drawingml/2006/main" prst="rect">
-            <a:avLst/>
-          </a:prstGeom>
-          <a:solidFill xmlns:a="http://schemas.openxmlformats.org/drawingml/2006/main">
-            <a:srgbClr val="000000">
-              <a:alpha val="0"/>
-            </a:srgbClr>
-          </a:solidFill>
-          <a:ln xmlns:a="http://schemas.openxmlformats.org/drawingml/2006/main" w="0">
-            <a:solidFill>
-              <a:srgbClr val="000000">
-                <a:alpha val="0"/>
-              </a:srgbClr>
-            </a:solidFill>
-            <a:prstDash val="solid"/>
-          </a:ln>
-        </p:spPr>
-        <p:txBody>
-          <a:bodyPr xmlns:a="http://schemas.openxmlformats.org/drawingml/2006/main" lIns="0" tIns="0" rIns="0" bIns="0" anchor="ctr" wrap="square"/>
-          <a:lstStyle xmlns:a="http://schemas.openxmlformats.org/drawingml/2006/main"/>
-          <a:p xmlns:a="http://schemas.openxmlformats.org/drawingml/2006/main">
-            <a:pPr algn="ctr">
-              <a:defRPr sz="1050" b="1">
-                <a:solidFill>
-                  <a:srgbClr val="20262A"/>
-                </a:solidFill>
-                <a:latin typeface="Aptos"/>
-                <a:ea typeface="Aptos"/>
-                <a:cs typeface="Aptos"/>
-              </a:defRPr>
-            </a:pPr>
-            <a:r>
-              <a:rPr sz="1050" b="1">
-                <a:solidFill>
-                  <a:srgbClr val="20262A"/>
-                </a:solidFill>
-                <a:latin typeface="Aptos"/>
-              </a:rPr>
-              <a:t>superseded → 2 sub-questions</a:t>
-            </a:r>
-          </a:p>
-        </p:txBody>
-      </p:sp>
-      <p:sp>
-        <p:nvSpPr>
-          <p:cNvPr id="11" name="box-one result">
-            <a:extLst xmlns:a="http://schemas.openxmlformats.org/drawingml/2006/main">
-              <a:ext uri="{FF2B5EF4-FFF2-40B4-BE49-F238E27FC236}">
-                <a16:creationId xmlns:a16="http://schemas.microsoft.com/office/drawing/2014/main" id="{E94C3B52-D86E-4012-947B-44A7372784C5}"/>
-              </a:ext>
-            </a:extLst>
-          </p:cNvPr>
-          <p:cNvSpPr>
-            <a:spLocks xmlns:a="http://schemas.openxmlformats.org/drawingml/2006/main" noGrp="1"/>
-          </p:cNvSpPr>
-          <p:nvPr/>
-        </p:nvSpPr>
-        <p:spPr>
-          <a:xfrm xmlns:a="http://schemas.openxmlformats.org/drawingml/2006/main">
-            <a:off x="8039100" y="3543300"/>
-            <a:ext cx="2190750" cy="647700"/>
-          </a:xfrm>
-          <a:prstGeom xmlns:a="http://schemas.openxmlformats.org/drawingml/2006/main" prst="rect">
-            <a:avLst/>
-          </a:prstGeom>
-          <a:solidFill xmlns:a="http://schemas.openxmlformats.org/drawingml/2006/main">
-            <a:srgbClr val="FFFFFF"/>
-          </a:solidFill>
-          <a:ln xmlns:a="http://schemas.openxmlformats.org/drawingml/2006/main" w="11430">
-            <a:solidFill>
-              <a:srgbClr val="20262A"/>
-            </a:solidFill>
-            <a:prstDash val="solid"/>
-          </a:ln>
-        </p:spPr>
-        <p:txBody xmlns:a="http://schemas.openxmlformats.org/drawingml/2006/main">
-          <a:bodyPr/>
-          <a:p/>
-        </p:txBody>
-      </p:sp>
-      <p:sp>
-        <p:nvSpPr>
-          <p:cNvPr id="12" name="label-one result">
-            <a:extLst xmlns:a="http://schemas.openxmlformats.org/drawingml/2006/main">
-              <a:ext uri="{FF2B5EF4-FFF2-40B4-BE49-F238E27FC236}">
-                <a16:creationId xmlns:a16="http://schemas.microsoft.com/office/drawing/2014/main" id="{32748925-9AFE-4CB6-B34D-63CB96B2524A}"/>
-              </a:ext>
-            </a:extLst>
-          </p:cNvPr>
-          <p:cNvSpPr>
-            <a:spLocks xmlns:a="http://schemas.openxmlformats.org/drawingml/2006/main" noGrp="1"/>
-          </p:cNvSpPr>
-          <p:nvPr/>
-        </p:nvSpPr>
-        <p:spPr>
-          <a:xfrm xmlns:a="http://schemas.openxmlformats.org/drawingml/2006/main">
-            <a:off x="8172450" y="3657600"/>
-            <a:ext cx="1924050" cy="419100"/>
-          </a:xfrm>
-          <a:prstGeom xmlns:a="http://schemas.openxmlformats.org/drawingml/2006/main" prst="rect">
-            <a:avLst/>
-          </a:prstGeom>
-          <a:solidFill xmlns:a="http://schemas.openxmlformats.org/drawingml/2006/main">
-            <a:srgbClr val="000000">
-              <a:alpha val="0"/>
-            </a:srgbClr>
-          </a:solidFill>
-          <a:ln xmlns:a="http://schemas.openxmlformats.org/drawingml/2006/main" w="0">
-            <a:solidFill>
-              <a:srgbClr val="000000">
-                <a:alpha val="0"/>
-              </a:srgbClr>
-            </a:solidFill>
-            <a:prstDash val="solid"/>
-          </a:ln>
-        </p:spPr>
-        <p:txBody>
-          <a:bodyPr xmlns:a="http://schemas.openxmlformats.org/drawingml/2006/main" lIns="0" tIns="0" rIns="0" bIns="0" anchor="ctr" wrap="square"/>
-          <a:lstStyle xmlns:a="http://schemas.openxmlformats.org/drawingml/2006/main"/>
-          <a:p xmlns:a="http://schemas.openxmlformats.org/drawingml/2006/main">
-            <a:pPr algn="ctr">
-              <a:defRPr sz="1050" b="0">
-                <a:solidFill>
-                  <a:srgbClr val="20262A"/>
-                </a:solidFill>
-                <a:latin typeface="Aptos"/>
-                <a:ea typeface="Aptos"/>
-                <a:cs typeface="Aptos"/>
-              </a:defRPr>
-            </a:pPr>
-            <a:r>
-              <a:rPr sz="1050" b="0">
-                <a:solidFill>
-                  <a:srgbClr val="20262A"/>
-                </a:solidFill>
-                <a:latin typeface="Aptos"/>
-              </a:rPr>
-              <a:t>Fig 3b</a:t>
-            </a:r>
-          </a:p>
-        </p:txBody>
-      </p:sp>
-      <p:sp>
-        <p:nvSpPr>
-          <p:cNvPr id="13" name="line-h">
-            <a:extLst xmlns:a="http://schemas.openxmlformats.org/drawingml/2006/main">
-              <a:ext uri="{FF2B5EF4-FFF2-40B4-BE49-F238E27FC236}">
-                <a16:creationId xmlns:a16="http://schemas.microsoft.com/office/drawing/2014/main" id="{D7118F78-65F1-47A4-AB74-B4931CADA2B0}"/>
-              </a:ext>
-            </a:extLst>
-          </p:cNvPr>
-          <p:cNvSpPr>
-            <a:spLocks xmlns:a="http://schemas.openxmlformats.org/drawingml/2006/main" noGrp="1"/>
-          </p:cNvSpPr>
-          <p:nvPr/>
-        </p:nvSpPr>
-        <p:spPr>
-          <a:xfrm xmlns:a="http://schemas.openxmlformats.org/drawingml/2006/main">
-            <a:off x="3943350" y="3867150"/>
-            <a:ext cx="723900" cy="19050"/>
-          </a:xfrm>
-          <a:prstGeom xmlns:a="http://schemas.openxmlformats.org/drawingml/2006/main" prst="rect">
-            <a:avLst/>
-          </a:prstGeom>
-          <a:solidFill xmlns:a="http://schemas.openxmlformats.org/drawingml/2006/main">
-            <a:srgbClr val="A8A198"/>
-          </a:solidFill>
-          <a:ln xmlns:a="http://schemas.openxmlformats.org/drawingml/2006/main" w="0">
-            <a:solidFill>
-              <a:srgbClr val="A8A198"/>
-            </a:solidFill>
-            <a:prstDash val="solid"/>
-          </a:ln>
-        </p:spPr>
-        <p:txBody xmlns:a="http://schemas.openxmlformats.org/drawingml/2006/main">
-          <a:bodyPr/>
-          <a:p/>
-        </p:txBody>
-      </p:sp>
-      <p:sp>
-        <p:nvSpPr>
-          <p:cNvPr id="14" name="line-h">
-            <a:extLst xmlns:a="http://schemas.openxmlformats.org/drawingml/2006/main">
-              <a:ext uri="{FF2B5EF4-FFF2-40B4-BE49-F238E27FC236}">
-                <a16:creationId xmlns:a16="http://schemas.microsoft.com/office/drawing/2014/main" id="{58AAAB16-242A-4112-85D8-1273784BF0E8}"/>
-              </a:ext>
-            </a:extLst>
-          </p:cNvPr>
-          <p:cNvSpPr>
-            <a:spLocks xmlns:a="http://schemas.openxmlformats.org/drawingml/2006/main" noGrp="1"/>
-          </p:cNvSpPr>
-          <p:nvPr/>
-        </p:nvSpPr>
-        <p:spPr>
-          <a:xfrm xmlns:a="http://schemas.openxmlformats.org/drawingml/2006/main">
-            <a:off x="7315200" y="3867150"/>
-            <a:ext cx="723900" cy="19050"/>
-          </a:xfrm>
-          <a:prstGeom xmlns:a="http://schemas.openxmlformats.org/drawingml/2006/main" prst="rect">
-            <a:avLst/>
-          </a:prstGeom>
-          <a:solidFill xmlns:a="http://schemas.openxmlformats.org/drawingml/2006/main">
-            <a:srgbClr val="A8A198"/>
-          </a:solidFill>
-          <a:ln xmlns:a="http://schemas.openxmlformats.org/drawingml/2006/main" w="0">
-            <a:solidFill>
-              <a:srgbClr val="A8A198"/>
-            </a:solidFill>
-            <a:prstDash val="solid"/>
-          </a:ln>
-        </p:spPr>
-        <p:txBody xmlns:a="http://schemas.openxmlformats.org/drawingml/2006/main">
-          <a:bodyPr/>
-          <a:p/>
-        </p:txBody>
-      </p:sp>
-      <p:sp>
-        <p:nvSpPr>
-          <p:cNvPr id="15" name="">
-            <a:extLst xmlns:a="http://schemas.openxmlformats.org/drawingml/2006/main">
-              <a:ext uri="{FF2B5EF4-FFF2-40B4-BE49-F238E27FC236}">
-                <a16:creationId xmlns:a16="http://schemas.microsoft.com/office/drawing/2014/main" id="{B566F625-C7D9-4257-A8D2-48DBEE610277}"/>
-              </a:ext>
-            </a:extLst>
-          </p:cNvPr>
-          <p:cNvSpPr>
-            <a:spLocks xmlns:a="http://schemas.openxmlformats.org/drawingml/2006/main" noGrp="1"/>
-          </p:cNvSpPr>
-          <p:nvPr/>
-        </p:nvSpPr>
-        <p:spPr>
-          <a:xfrm xmlns:a="http://schemas.openxmlformats.org/drawingml/2006/main">
-            <a:off x="1676400" y="4781550"/>
-            <a:ext cx="8572500" cy="323850"/>
-          </a:xfrm>
-          <a:prstGeom xmlns:a="http://schemas.openxmlformats.org/drawingml/2006/main" prst="rect">
-            <a:avLst/>
-          </a:prstGeom>
-          <a:solidFill xmlns:a="http://schemas.openxmlformats.org/drawingml/2006/main">
-            <a:srgbClr val="000000">
-              <a:alpha val="0"/>
-            </a:srgbClr>
-          </a:solidFill>
-          <a:ln xmlns:a="http://schemas.openxmlformats.org/drawingml/2006/main" w="0">
-            <a:solidFill>
-              <a:srgbClr val="000000">
-                <a:alpha val="0"/>
-              </a:srgbClr>
-            </a:solidFill>
-            <a:prstDash val="solid"/>
-          </a:ln>
-        </p:spPr>
-        <p:txBody>
-          <a:bodyPr xmlns:a="http://schemas.openxmlformats.org/drawingml/2006/main" lIns="0" tIns="0" rIns="0" bIns="0" anchor="ctr"/>
-          <a:lstStyle xmlns:a="http://schemas.openxmlformats.org/drawingml/2006/main"/>
-          <a:p xmlns:a="http://schemas.openxmlformats.org/drawingml/2006/main">
-            <a:pPr algn="ctr">
-              <a:defRPr sz="1125" b="0">
-                <a:solidFill>
-                  <a:srgbClr val="20262A"/>
-                </a:solidFill>
-                <a:latin typeface="Aptos"/>
-                <a:ea typeface="Aptos"/>
-                <a:cs typeface="Aptos"/>
-              </a:defRPr>
-            </a:pPr>
-            <a:r>
-              <a:rPr sz="1125" b="0">
-                <a:solidFill>
-                  <a:srgbClr val="20262A"/>
-                </a:solidFill>
-                <a:latin typeface="Aptos"/>
-                <a:ea typeface="Aptos"/>
-                <a:cs typeface="Aptos"/>
-              </a:rPr>
-              <a:t>Discussion: which project is suitable, what capture friction matters, and what context assistants need.</a:t>
-            </a:r>
-          </a:p>
-        </p:txBody>
-      </p:sp>
+      <p:pic xmlns:a="http://schemas.openxmlformats.org/drawingml/2006/main" xmlns:r="http://schemas.openxmlformats.org/officeDocument/2006/relationships">
+        <p:nvPicPr>
+          <p:cNvPr id="7" name="Picture 6" descr="project-graph-full.png"/>
+          <p:cNvPicPr>
+            <a:picLocks noChangeAspect="1"/>
+          </p:cNvPicPr>
+          <p:nvPr/>
+        </p:nvPicPr>
+        <p:blipFill>
+          <a:blip r:embed="rId3"/>
+          <a:stretch>
+            <a:fillRect/>
+          </a:stretch>
+        </p:blipFill>
+        <p:spPr>
+          <a:xfrm>
+            <a:off x="3692853" y="2240280"/>
+            <a:ext cx="4775812" cy="3886200"/>
+          </a:xfrm>
+          <a:prstGeom prst="rect">
+            <a:avLst/>
+          </a:prstGeom>
+        </p:spPr>
+      </p:pic>
     </p:spTree>
     <p:extLst>
       <p:ext uri="{BB962C8B-B14F-4D97-AF65-F5344CB8AC3E}">

</xml_diff>